<commit_message>
docs: decks with metrics config (slides_src), updated QA facts, roadmap; demo script FU19 4/7 optional
</commit_message>
<xml_diff>
--- a/docs/presentation.pptx
+++ b/docs/presentation.pptx
@@ -948,7 +948,7 @@
           <a:p>
             <a:r>
               <a:rPr lang="en-US" dirty="0"/>
-              <a:t>Цифры на текущей версии (main 0c9b8c7, эталонные ответы зафиксированы до прогона). Основной набор, 45 кейсов: верный код на первом месте 44 из 45 — 98%, в тройке — все 45. Отложенный набор — 45 новых позиций, под которые код не подстраивался: на первом месте 43 из 45 — 96%, в тройке 44 из 45 — 98%, статус верный 43 из 45. По доменам: мебель 15 из 15, инструменты 15 из 15, одежда 13 из 15. Ложных тревог на чистых кейсах — 1 из 42. Скорость: медиана около 50 мс, p95 около 100–115 мс по замеру eval-скрипта; чистая сборка индекса — 71 с. Демо: мебель, одежда, инструменты — от свободного текста до кода КТРУ; показываем таблицу с бейджами, исправление в один клик и воронку N → M → 1. Если спросят об ограничениях: внесённые ошибки ловятся в 19 из 30 случаев — единицы 8/8, нереалистичные числа 7/8, опечатки 4/7, несуществующие значения 0/7; это следующий шаг.</a:t>
+              <a:t>Цифры на текущей версии, эталонные ответы зафиксированы до прогона. Основной набор, 45 кейсов: верный код на первом месте 44/45 — 98%, в тройке — 45/45. Отложенный набор — 45 новых позиций, под которые код не подстраивался: на первом месте 43/45 — 96%, в тройке 44/45 — 98%, статус верный 43/45. По доменам: мебель 15/15, инструменты 15/15, одежда 13/15. Ложных тревог на чистых кейсах — 1/42. Скорость: медиана ~50 мс, p95 99–164 мс по замеру eval-скрипта; 50 параллельных запросов — без ошибок. Справочник — 3391 позиция КТРУ, весь архив; чистая сборка индекса — ~100 с; 58 автотестов pytest. Демо: мебель, одежда, инструменты — от свободного текста до кода КТРУ; показываем таблицу с бейджами и исправление в один клик; на выходе группа из 2–3 вариаций — это нормально, различия задают обязательные характеристики. Если спросят об ограничениях: внесённые ошибки ловятся не все — опечатки и отдельные нереалистичные числа пока пропускаются; проверку несуществующих значений уже добавили.</a:t>
             </a:r>
             <a:endParaRPr lang="en-US" dirty="0"/>
           </a:p>
@@ -6016,7 +6016,7 @@
                 <a:ea typeface="Inter" pitchFamily="34" charset="-122"/>
                 <a:cs typeface="Inter" pitchFamily="34" charset="-120"/>
               </a:rPr>
-              <a:t>Цифры на текущей версии · main 0c9b8c7</a:t>
+              <a:t>Цифры на текущей версии</a:t>
             </a:r>
             <a:endParaRPr lang="en-US" sz="1150" dirty="0"/>
           </a:p>
@@ -6548,7 +6548,7 @@
       </p:sp>
       <p:graphicFrame>
         <p:nvGraphicFramePr>
-          <p:cNvPr id="37" name="Table 0"/>
+          <p:cNvPr id="36" name="Table 0"/>
           <p:cNvGraphicFramePr>
             <a:graphicFrameLocks noGrp="1"/>
           </p:cNvGraphicFramePr>
@@ -6572,7 +6572,7 @@
                 <a:gridCol w="3017520"/>
                 <a:gridCol w="2240280"/>
               </a:tblGrid>
-              <a:tr h="365760">
+              <a:tr h="301752">
                 <a:tc>
                   <a:txBody>
                     <a:bodyPr/>
@@ -6582,7 +6582,7 @@
                         <a:buNone/>
                       </a:pPr>
                       <a:r>
-                        <a:rPr lang="en-US" sz="1250" b="1" dirty="0">
+                        <a:rPr lang="en-US" sz="1200" b="1" dirty="0">
                           <a:solidFill>
                             <a:srgbClr val="FFFFFF"/>
                           </a:solidFill>
@@ -6592,14 +6592,14 @@
                         </a:rPr>
                         <a:t>Метрика</a:t>
                       </a:r>
-                      <a:endParaRPr lang="en-US" sz="1250" dirty="0">
+                      <a:endParaRPr lang="en-US" sz="1200" dirty="0">
                         <a:latin typeface="Inter" charset="0"/>
                         <a:ea typeface="Inter" charset="0"/>
                         <a:cs typeface="Inter" charset="0"/>
                       </a:endParaRPr>
                     </a:p>
                   </a:txBody>
-                  <a:tcPr marL="64008" marR="64008" marT="64008" marB="64008" anchor="ctr">
+                  <a:tcPr marL="54864" marR="54864" marT="54864" marB="54864" anchor="ctr">
                     <a:lnL w="9525" cap="flat" cmpd="sng" algn="ctr">
                       <a:solidFill>
                         <a:srgbClr val="D5DCE6"/>
@@ -6650,7 +6650,7 @@
                         <a:buNone/>
                       </a:pPr>
                       <a:r>
-                        <a:rPr lang="en-US" sz="1250" b="1" dirty="0">
+                        <a:rPr lang="en-US" sz="1200" b="1" dirty="0">
                           <a:solidFill>
                             <a:srgbClr val="FFFFFF"/>
                           </a:solidFill>
@@ -6660,14 +6660,14 @@
                         </a:rPr>
                         <a:t>Значение</a:t>
                       </a:r>
-                      <a:endParaRPr lang="en-US" sz="1250" dirty="0">
+                      <a:endParaRPr lang="en-US" sz="1200" dirty="0">
                         <a:latin typeface="Inter" charset="0"/>
                         <a:ea typeface="Inter" charset="0"/>
                         <a:cs typeface="Inter" charset="0"/>
                       </a:endParaRPr>
                     </a:p>
                   </a:txBody>
-                  <a:tcPr marL="64008" marR="64008" marT="64008" marB="64008" anchor="ctr">
+                  <a:tcPr marL="54864" marR="54864" marT="54864" marB="54864" anchor="ctr">
                     <a:lnL w="9525" cap="flat" cmpd="sng" algn="ctr">
                       <a:solidFill>
                         <a:srgbClr val="D5DCE6"/>
@@ -6710,7 +6710,7 @@
                   </a:tcPr>
                 </a:tc>
               </a:tr>
-              <a:tr h="365760">
+              <a:tr h="301752">
                 <a:tc>
                   <a:txBody>
                     <a:bodyPr/>
@@ -6720,7 +6720,7 @@
                         <a:buNone/>
                       </a:pPr>
                       <a:r>
-                        <a:rPr lang="en-US" sz="1250" dirty="0">
+                        <a:rPr lang="en-US" sz="1200" dirty="0">
                           <a:solidFill>
                             <a:srgbClr val="1F2A3C"/>
                           </a:solidFill>
@@ -6730,14 +6730,14 @@
                         </a:rPr>
                         <a:t>Статус верный (отложенный)</a:t>
                       </a:r>
-                      <a:endParaRPr lang="en-US" sz="1250" dirty="0">
+                      <a:endParaRPr lang="en-US" sz="1200" dirty="0">
                         <a:latin typeface="Inter" charset="0"/>
                         <a:ea typeface="Inter" charset="0"/>
                         <a:cs typeface="Inter" charset="0"/>
                       </a:endParaRPr>
                     </a:p>
                   </a:txBody>
-                  <a:tcPr marL="64008" marR="64008" marT="64008" marB="64008" anchor="ctr">
+                  <a:tcPr marL="54864" marR="54864" marT="54864" marB="54864" anchor="ctr">
                     <a:lnL w="9525" cap="flat" cmpd="sng" algn="ctr">
                       <a:solidFill>
                         <a:srgbClr val="D5DCE6"/>
@@ -6785,7 +6785,7 @@
                         <a:buNone/>
                       </a:pPr>
                       <a:r>
-                        <a:rPr lang="en-US" sz="1250" b="1" dirty="0">
+                        <a:rPr lang="en-US" sz="1200" b="1" dirty="0">
                           <a:solidFill>
                             <a:srgbClr val="264B82"/>
                           </a:solidFill>
@@ -6795,14 +6795,14 @@
                         </a:rPr>
                         <a:t>43/45 · 96%</a:t>
                       </a:r>
-                      <a:endParaRPr lang="en-US" sz="1250" dirty="0">
+                      <a:endParaRPr lang="en-US" sz="1200" dirty="0">
                         <a:latin typeface="Inter" charset="0"/>
                         <a:ea typeface="Inter" charset="0"/>
                         <a:cs typeface="Inter" charset="0"/>
                       </a:endParaRPr>
                     </a:p>
                   </a:txBody>
-                  <a:tcPr marL="64008" marR="64008" marT="64008" marB="64008" anchor="ctr">
+                  <a:tcPr marL="54864" marR="54864" marT="54864" marB="54864" anchor="ctr">
                     <a:lnL w="9525" cap="flat" cmpd="sng" algn="ctr">
                       <a:solidFill>
                         <a:srgbClr val="D5DCE6"/>
@@ -6842,7 +6842,7 @@
                   </a:tcPr>
                 </a:tc>
               </a:tr>
-              <a:tr h="365760">
+              <a:tr h="301752">
                 <a:tc>
                   <a:txBody>
                     <a:bodyPr/>
@@ -6852,7 +6852,7 @@
                         <a:buNone/>
                       </a:pPr>
                       <a:r>
-                        <a:rPr lang="en-US" sz="1250" dirty="0">
+                        <a:rPr lang="en-US" sz="1200" dirty="0">
                           <a:solidFill>
                             <a:srgbClr val="1F2A3C"/>
                           </a:solidFill>
@@ -6862,14 +6862,14 @@
                         </a:rPr>
                         <a:t>Мебель / инструменты / одежда</a:t>
                       </a:r>
-                      <a:endParaRPr lang="en-US" sz="1250" dirty="0">
+                      <a:endParaRPr lang="en-US" sz="1200" dirty="0">
                         <a:latin typeface="Inter" charset="0"/>
                         <a:ea typeface="Inter" charset="0"/>
                         <a:cs typeface="Inter" charset="0"/>
                       </a:endParaRPr>
                     </a:p>
                   </a:txBody>
-                  <a:tcPr marL="64008" marR="64008" marT="64008" marB="64008" anchor="ctr">
+                  <a:tcPr marL="54864" marR="54864" marT="54864" marB="54864" anchor="ctr">
                     <a:lnL w="9525" cap="flat" cmpd="sng" algn="ctr">
                       <a:solidFill>
                         <a:srgbClr val="D5DCE6"/>
@@ -6917,7 +6917,7 @@
                         <a:buNone/>
                       </a:pPr>
                       <a:r>
-                        <a:rPr lang="en-US" sz="1250" b="1" dirty="0">
+                        <a:rPr lang="en-US" sz="1200" b="1" dirty="0">
                           <a:solidFill>
                             <a:srgbClr val="264B82"/>
                           </a:solidFill>
@@ -6927,14 +6927,14 @@
                         </a:rPr>
                         <a:t>15/15 · 15/15 · 13/15</a:t>
                       </a:r>
-                      <a:endParaRPr lang="en-US" sz="1250" dirty="0">
+                      <a:endParaRPr lang="en-US" sz="1200" dirty="0">
                         <a:latin typeface="Inter" charset="0"/>
                         <a:ea typeface="Inter" charset="0"/>
                         <a:cs typeface="Inter" charset="0"/>
                       </a:endParaRPr>
                     </a:p>
                   </a:txBody>
-                  <a:tcPr marL="64008" marR="64008" marT="64008" marB="64008" anchor="ctr">
+                  <a:tcPr marL="54864" marR="54864" marT="54864" marB="54864" anchor="ctr">
                     <a:lnL w="9525" cap="flat" cmpd="sng" algn="ctr">
                       <a:solidFill>
                         <a:srgbClr val="D5DCE6"/>
@@ -6974,7 +6974,7 @@
                   </a:tcPr>
                 </a:tc>
               </a:tr>
-              <a:tr h="365760">
+              <a:tr h="301752">
                 <a:tc>
                   <a:txBody>
                     <a:bodyPr/>
@@ -6984,7 +6984,7 @@
                         <a:buNone/>
                       </a:pPr>
                       <a:r>
-                        <a:rPr lang="en-US" sz="1250" dirty="0">
+                        <a:rPr lang="en-US" sz="1200" dirty="0">
                           <a:solidFill>
                             <a:srgbClr val="1F2A3C"/>
                           </a:solidFill>
@@ -6994,14 +6994,14 @@
                         </a:rPr>
                         <a:t>Ложные тревоги на чистых</a:t>
                       </a:r>
-                      <a:endParaRPr lang="en-US" sz="1250" dirty="0">
+                      <a:endParaRPr lang="en-US" sz="1200" dirty="0">
                         <a:latin typeface="Inter" charset="0"/>
                         <a:ea typeface="Inter" charset="0"/>
                         <a:cs typeface="Inter" charset="0"/>
                       </a:endParaRPr>
                     </a:p>
                   </a:txBody>
-                  <a:tcPr marL="64008" marR="64008" marT="64008" marB="64008" anchor="ctr">
+                  <a:tcPr marL="54864" marR="54864" marT="54864" marB="54864" anchor="ctr">
                     <a:lnL w="9525" cap="flat" cmpd="sng" algn="ctr">
                       <a:solidFill>
                         <a:srgbClr val="D5DCE6"/>
@@ -7049,7 +7049,7 @@
                         <a:buNone/>
                       </a:pPr>
                       <a:r>
-                        <a:rPr lang="en-US" sz="1250" b="1" dirty="0">
+                        <a:rPr lang="en-US" sz="1200" b="1" dirty="0">
                           <a:solidFill>
                             <a:srgbClr val="264B82"/>
                           </a:solidFill>
@@ -7059,14 +7059,14 @@
                         </a:rPr>
                         <a:t>1/42</a:t>
                       </a:r>
-                      <a:endParaRPr lang="en-US" sz="1250" dirty="0">
+                      <a:endParaRPr lang="en-US" sz="1200" dirty="0">
                         <a:latin typeface="Inter" charset="0"/>
                         <a:ea typeface="Inter" charset="0"/>
                         <a:cs typeface="Inter" charset="0"/>
                       </a:endParaRPr>
                     </a:p>
                   </a:txBody>
-                  <a:tcPr marL="64008" marR="64008" marT="64008" marB="64008" anchor="ctr">
+                  <a:tcPr marL="54864" marR="54864" marT="54864" marB="54864" anchor="ctr">
                     <a:lnL w="9525" cap="flat" cmpd="sng" algn="ctr">
                       <a:solidFill>
                         <a:srgbClr val="D5DCE6"/>
@@ -7106,7 +7106,7 @@
                   </a:tcPr>
                 </a:tc>
               </a:tr>
-              <a:tr h="365760">
+              <a:tr h="301752">
                 <a:tc>
                   <a:txBody>
                     <a:bodyPr/>
@@ -7116,7 +7116,7 @@
                         <a:buNone/>
                       </a:pPr>
                       <a:r>
-                        <a:rPr lang="en-US" sz="1250" dirty="0">
+                        <a:rPr lang="en-US" sz="1200" dirty="0">
                           <a:solidFill>
                             <a:srgbClr val="1F2A3C"/>
                           </a:solidFill>
@@ -7126,14 +7126,14 @@
                         </a:rPr>
                         <a:t>Время ответа: медиана</a:t>
                       </a:r>
-                      <a:endParaRPr lang="en-US" sz="1250" dirty="0">
+                      <a:endParaRPr lang="en-US" sz="1200" dirty="0">
                         <a:latin typeface="Inter" charset="0"/>
                         <a:ea typeface="Inter" charset="0"/>
                         <a:cs typeface="Inter" charset="0"/>
                       </a:endParaRPr>
                     </a:p>
                   </a:txBody>
-                  <a:tcPr marL="64008" marR="64008" marT="64008" marB="64008" anchor="ctr">
+                  <a:tcPr marL="54864" marR="54864" marT="54864" marB="54864" anchor="ctr">
                     <a:lnL w="9525" cap="flat" cmpd="sng" algn="ctr">
                       <a:solidFill>
                         <a:srgbClr val="D5DCE6"/>
@@ -7181,7 +7181,7 @@
                         <a:buNone/>
                       </a:pPr>
                       <a:r>
-                        <a:rPr lang="en-US" sz="1250" b="1" dirty="0">
+                        <a:rPr lang="en-US" sz="1200" b="1" dirty="0">
                           <a:solidFill>
                             <a:srgbClr val="264B82"/>
                           </a:solidFill>
@@ -7191,14 +7191,14 @@
                         </a:rPr>
                         <a:t>~50 мс</a:t>
                       </a:r>
-                      <a:endParaRPr lang="en-US" sz="1250" dirty="0">
+                      <a:endParaRPr lang="en-US" sz="1200" dirty="0">
                         <a:latin typeface="Inter" charset="0"/>
                         <a:ea typeface="Inter" charset="0"/>
                         <a:cs typeface="Inter" charset="0"/>
                       </a:endParaRPr>
                     </a:p>
                   </a:txBody>
-                  <a:tcPr marL="64008" marR="64008" marT="64008" marB="64008" anchor="ctr">
+                  <a:tcPr marL="54864" marR="54864" marT="54864" marB="54864" anchor="ctr">
                     <a:lnL w="9525" cap="flat" cmpd="sng" algn="ctr">
                       <a:solidFill>
                         <a:srgbClr val="D5DCE6"/>
@@ -7238,7 +7238,7 @@
                   </a:tcPr>
                 </a:tc>
               </a:tr>
-              <a:tr h="365760">
+              <a:tr h="301752">
                 <a:tc>
                   <a:txBody>
                     <a:bodyPr/>
@@ -7248,7 +7248,7 @@
                         <a:buNone/>
                       </a:pPr>
                       <a:r>
-                        <a:rPr lang="en-US" sz="1250" dirty="0">
+                        <a:rPr lang="en-US" sz="1200" dirty="0">
                           <a:solidFill>
                             <a:srgbClr val="1F2A3C"/>
                           </a:solidFill>
@@ -7256,16 +7256,16 @@
                           <a:ea typeface="Inter" pitchFamily="34" charset="-122"/>
                           <a:cs typeface="Inter" pitchFamily="34" charset="-120"/>
                         </a:rPr>
-                        <a:t>Время ответа: p95</a:t>
+                        <a:t>Время ответа: p95*</a:t>
                       </a:r>
-                      <a:endParaRPr lang="en-US" sz="1250" dirty="0">
+                      <a:endParaRPr lang="en-US" sz="1200" dirty="0">
                         <a:latin typeface="Inter" charset="0"/>
                         <a:ea typeface="Inter" charset="0"/>
                         <a:cs typeface="Inter" charset="0"/>
                       </a:endParaRPr>
                     </a:p>
                   </a:txBody>
-                  <a:tcPr marL="64008" marR="64008" marT="64008" marB="64008" anchor="ctr">
+                  <a:tcPr marL="54864" marR="54864" marT="54864" marB="54864" anchor="ctr">
                     <a:lnL w="9525" cap="flat" cmpd="sng" algn="ctr">
                       <a:solidFill>
                         <a:srgbClr val="D5DCE6"/>
@@ -7313,7 +7313,7 @@
                         <a:buNone/>
                       </a:pPr>
                       <a:r>
-                        <a:rPr lang="en-US" sz="1250" b="1" dirty="0">
+                        <a:rPr lang="en-US" sz="1200" b="1" dirty="0">
                           <a:solidFill>
                             <a:srgbClr val="264B82"/>
                           </a:solidFill>
@@ -7321,16 +7321,16 @@
                           <a:ea typeface="Inter" pitchFamily="34" charset="-122"/>
                           <a:cs typeface="Inter" pitchFamily="34" charset="-120"/>
                         </a:rPr>
-                        <a:t>~100–115 мс</a:t>
+                        <a:t>99–164 мс</a:t>
                       </a:r>
-                      <a:endParaRPr lang="en-US" sz="1250" dirty="0">
+                      <a:endParaRPr lang="en-US" sz="1200" dirty="0">
                         <a:latin typeface="Inter" charset="0"/>
                         <a:ea typeface="Inter" charset="0"/>
                         <a:cs typeface="Inter" charset="0"/>
                       </a:endParaRPr>
                     </a:p>
                   </a:txBody>
-                  <a:tcPr marL="64008" marR="64008" marT="64008" marB="64008" anchor="ctr">
+                  <a:tcPr marL="54864" marR="54864" marT="54864" marB="54864" anchor="ctr">
                     <a:lnL w="9525" cap="flat" cmpd="sng" algn="ctr">
                       <a:solidFill>
                         <a:srgbClr val="D5DCE6"/>
@@ -7370,7 +7370,7 @@
                   </a:tcPr>
                 </a:tc>
               </a:tr>
-              <a:tr h="365760">
+              <a:tr h="301752">
                 <a:tc>
                   <a:txBody>
                     <a:bodyPr/>
@@ -7380,7 +7380,7 @@
                         <a:buNone/>
                       </a:pPr>
                       <a:r>
-                        <a:rPr lang="en-US" sz="1250" dirty="0">
+                        <a:rPr lang="en-US" sz="1200" dirty="0">
                           <a:solidFill>
                             <a:srgbClr val="1F2A3C"/>
                           </a:solidFill>
@@ -7388,16 +7388,16 @@
                           <a:ea typeface="Inter" pitchFamily="34" charset="-122"/>
                           <a:cs typeface="Inter" pitchFamily="34" charset="-120"/>
                         </a:rPr>
-                        <a:t>Чистая сборка индекса</a:t>
+                        <a:t>Нагрузка: параллельных запросов</a:t>
                       </a:r>
-                      <a:endParaRPr lang="en-US" sz="1250" dirty="0">
+                      <a:endParaRPr lang="en-US" sz="1200" dirty="0">
                         <a:latin typeface="Inter" charset="0"/>
                         <a:ea typeface="Inter" charset="0"/>
                         <a:cs typeface="Inter" charset="0"/>
                       </a:endParaRPr>
                     </a:p>
                   </a:txBody>
-                  <a:tcPr marL="64008" marR="64008" marT="64008" marB="64008" anchor="ctr">
+                  <a:tcPr marL="54864" marR="54864" marT="54864" marB="54864" anchor="ctr">
                     <a:lnL w="9525" cap="flat" cmpd="sng" algn="ctr">
                       <a:solidFill>
                         <a:srgbClr val="D5DCE6"/>
@@ -7445,7 +7445,7 @@
                         <a:buNone/>
                       </a:pPr>
                       <a:r>
-                        <a:rPr lang="en-US" sz="1250" b="1" dirty="0">
+                        <a:rPr lang="en-US" sz="1200" b="1" dirty="0">
                           <a:solidFill>
                             <a:srgbClr val="264B82"/>
                           </a:solidFill>
@@ -7453,16 +7453,412 @@
                           <a:ea typeface="Inter" pitchFamily="34" charset="-122"/>
                           <a:cs typeface="Inter" pitchFamily="34" charset="-120"/>
                         </a:rPr>
-                        <a:t>71 с</a:t>
+                        <a:t>50 без ошибок</a:t>
                       </a:r>
-                      <a:endParaRPr lang="en-US" sz="1250" dirty="0">
+                      <a:endParaRPr lang="en-US" sz="1200" dirty="0">
                         <a:latin typeface="Inter" charset="0"/>
                         <a:ea typeface="Inter" charset="0"/>
                         <a:cs typeface="Inter" charset="0"/>
                       </a:endParaRPr>
                     </a:p>
                   </a:txBody>
-                  <a:tcPr marL="64008" marR="64008" marT="64008" marB="64008" anchor="ctr">
+                  <a:tcPr marL="54864" marR="54864" marT="54864" marB="54864" anchor="ctr">
+                    <a:lnL w="9525" cap="flat" cmpd="sng" algn="ctr">
+                      <a:solidFill>
+                        <a:srgbClr val="D5DCE6"/>
+                      </a:solidFill>
+                      <a:prstDash val="solid"/>
+                      <a:round/>
+                      <a:headEnd type="none" w="med" len="med"/>
+                      <a:tailEnd type="none" w="med" len="med"/>
+                    </a:lnL>
+                    <a:lnR w="9525" cap="flat" cmpd="sng" algn="ctr">
+                      <a:solidFill>
+                        <a:srgbClr val="D5DCE6"/>
+                      </a:solidFill>
+                      <a:prstDash val="solid"/>
+                      <a:round/>
+                      <a:headEnd type="none" w="med" len="med"/>
+                      <a:tailEnd type="none" w="med" len="med"/>
+                    </a:lnR>
+                    <a:lnT w="9525" cap="flat" cmpd="sng" algn="ctr">
+                      <a:solidFill>
+                        <a:srgbClr val="D5DCE6"/>
+                      </a:solidFill>
+                      <a:prstDash val="solid"/>
+                      <a:round/>
+                      <a:headEnd type="none" w="med" len="med"/>
+                      <a:tailEnd type="none" w="med" len="med"/>
+                    </a:lnT>
+                    <a:lnB w="9525" cap="flat" cmpd="sng" algn="ctr">
+                      <a:solidFill>
+                        <a:srgbClr val="D5DCE6"/>
+                      </a:solidFill>
+                      <a:prstDash val="solid"/>
+                      <a:round/>
+                      <a:headEnd type="none" w="med" len="med"/>
+                      <a:tailEnd type="none" w="med" len="med"/>
+                    </a:lnB>
+                  </a:tcPr>
+                </a:tc>
+              </a:tr>
+              <a:tr h="301752">
+                <a:tc>
+                  <a:txBody>
+                    <a:bodyPr/>
+                    <a:lstStyle/>
+                    <a:p>
+                      <a:pPr indent="0" marL="0">
+                        <a:buNone/>
+                      </a:pPr>
+                      <a:r>
+                        <a:rPr lang="en-US" sz="1200" dirty="0">
+                          <a:solidFill>
+                            <a:srgbClr val="1F2A3C"/>
+                          </a:solidFill>
+                          <a:latin typeface="Inter" pitchFamily="34" charset="0"/>
+                          <a:ea typeface="Inter" pitchFamily="34" charset="-122"/>
+                          <a:cs typeface="Inter" pitchFamily="34" charset="-120"/>
+                        </a:rPr>
+                        <a:t>Справочник КТРУ (весь архив)</a:t>
+                      </a:r>
+                      <a:endParaRPr lang="en-US" sz="1200" dirty="0">
+                        <a:latin typeface="Inter" charset="0"/>
+                        <a:ea typeface="Inter" charset="0"/>
+                        <a:cs typeface="Inter" charset="0"/>
+                      </a:endParaRPr>
+                    </a:p>
+                  </a:txBody>
+                  <a:tcPr marL="54864" marR="54864" marT="54864" marB="54864" anchor="ctr">
+                    <a:lnL w="9525" cap="flat" cmpd="sng" algn="ctr">
+                      <a:solidFill>
+                        <a:srgbClr val="D5DCE6"/>
+                      </a:solidFill>
+                      <a:prstDash val="solid"/>
+                      <a:round/>
+                      <a:headEnd type="none" w="med" len="med"/>
+                      <a:tailEnd type="none" w="med" len="med"/>
+                    </a:lnL>
+                    <a:lnR w="9525" cap="flat" cmpd="sng" algn="ctr">
+                      <a:solidFill>
+                        <a:srgbClr val="D5DCE6"/>
+                      </a:solidFill>
+                      <a:prstDash val="solid"/>
+                      <a:round/>
+                      <a:headEnd type="none" w="med" len="med"/>
+                      <a:tailEnd type="none" w="med" len="med"/>
+                    </a:lnR>
+                    <a:lnT w="9525" cap="flat" cmpd="sng" algn="ctr">
+                      <a:solidFill>
+                        <a:srgbClr val="D5DCE6"/>
+                      </a:solidFill>
+                      <a:prstDash val="solid"/>
+                      <a:round/>
+                      <a:headEnd type="none" w="med" len="med"/>
+                      <a:tailEnd type="none" w="med" len="med"/>
+                    </a:lnT>
+                    <a:lnB w="9525" cap="flat" cmpd="sng" algn="ctr">
+                      <a:solidFill>
+                        <a:srgbClr val="D5DCE6"/>
+                      </a:solidFill>
+                      <a:prstDash val="solid"/>
+                      <a:round/>
+                      <a:headEnd type="none" w="med" len="med"/>
+                      <a:tailEnd type="none" w="med" len="med"/>
+                    </a:lnB>
+                  </a:tcPr>
+                </a:tc>
+                <a:tc>
+                  <a:txBody>
+                    <a:bodyPr/>
+                    <a:lstStyle/>
+                    <a:p>
+                      <a:pPr algn="r" indent="0" marL="0">
+                        <a:buNone/>
+                      </a:pPr>
+                      <a:r>
+                        <a:rPr lang="en-US" sz="1200" b="1" dirty="0">
+                          <a:solidFill>
+                            <a:srgbClr val="264B82"/>
+                          </a:solidFill>
+                          <a:latin typeface="Inter" pitchFamily="34" charset="0"/>
+                          <a:ea typeface="Inter" pitchFamily="34" charset="-122"/>
+                          <a:cs typeface="Inter" pitchFamily="34" charset="-120"/>
+                        </a:rPr>
+                        <a:t>3391 позиция</a:t>
+                      </a:r>
+                      <a:endParaRPr lang="en-US" sz="1200" dirty="0">
+                        <a:latin typeface="Inter" charset="0"/>
+                        <a:ea typeface="Inter" charset="0"/>
+                        <a:cs typeface="Inter" charset="0"/>
+                      </a:endParaRPr>
+                    </a:p>
+                  </a:txBody>
+                  <a:tcPr marL="54864" marR="54864" marT="54864" marB="54864" anchor="ctr">
+                    <a:lnL w="9525" cap="flat" cmpd="sng" algn="ctr">
+                      <a:solidFill>
+                        <a:srgbClr val="D5DCE6"/>
+                      </a:solidFill>
+                      <a:prstDash val="solid"/>
+                      <a:round/>
+                      <a:headEnd type="none" w="med" len="med"/>
+                      <a:tailEnd type="none" w="med" len="med"/>
+                    </a:lnL>
+                    <a:lnR w="9525" cap="flat" cmpd="sng" algn="ctr">
+                      <a:solidFill>
+                        <a:srgbClr val="D5DCE6"/>
+                      </a:solidFill>
+                      <a:prstDash val="solid"/>
+                      <a:round/>
+                      <a:headEnd type="none" w="med" len="med"/>
+                      <a:tailEnd type="none" w="med" len="med"/>
+                    </a:lnR>
+                    <a:lnT w="9525" cap="flat" cmpd="sng" algn="ctr">
+                      <a:solidFill>
+                        <a:srgbClr val="D5DCE6"/>
+                      </a:solidFill>
+                      <a:prstDash val="solid"/>
+                      <a:round/>
+                      <a:headEnd type="none" w="med" len="med"/>
+                      <a:tailEnd type="none" w="med" len="med"/>
+                    </a:lnT>
+                    <a:lnB w="9525" cap="flat" cmpd="sng" algn="ctr">
+                      <a:solidFill>
+                        <a:srgbClr val="D5DCE6"/>
+                      </a:solidFill>
+                      <a:prstDash val="solid"/>
+                      <a:round/>
+                      <a:headEnd type="none" w="med" len="med"/>
+                      <a:tailEnd type="none" w="med" len="med"/>
+                    </a:lnB>
+                  </a:tcPr>
+                </a:tc>
+              </a:tr>
+              <a:tr h="301752">
+                <a:tc>
+                  <a:txBody>
+                    <a:bodyPr/>
+                    <a:lstStyle/>
+                    <a:p>
+                      <a:pPr indent="0" marL="0">
+                        <a:buNone/>
+                      </a:pPr>
+                      <a:r>
+                        <a:rPr lang="en-US" sz="1200" dirty="0">
+                          <a:solidFill>
+                            <a:srgbClr val="1F2A3C"/>
+                          </a:solidFill>
+                          <a:latin typeface="Inter" pitchFamily="34" charset="0"/>
+                          <a:ea typeface="Inter" pitchFamily="34" charset="-122"/>
+                          <a:cs typeface="Inter" pitchFamily="34" charset="-120"/>
+                        </a:rPr>
+                        <a:t>Автотесты pytest</a:t>
+                      </a:r>
+                      <a:endParaRPr lang="en-US" sz="1200" dirty="0">
+                        <a:latin typeface="Inter" charset="0"/>
+                        <a:ea typeface="Inter" charset="0"/>
+                        <a:cs typeface="Inter" charset="0"/>
+                      </a:endParaRPr>
+                    </a:p>
+                  </a:txBody>
+                  <a:tcPr marL="54864" marR="54864" marT="54864" marB="54864" anchor="ctr">
+                    <a:lnL w="9525" cap="flat" cmpd="sng" algn="ctr">
+                      <a:solidFill>
+                        <a:srgbClr val="D5DCE6"/>
+                      </a:solidFill>
+                      <a:prstDash val="solid"/>
+                      <a:round/>
+                      <a:headEnd type="none" w="med" len="med"/>
+                      <a:tailEnd type="none" w="med" len="med"/>
+                    </a:lnL>
+                    <a:lnR w="9525" cap="flat" cmpd="sng" algn="ctr">
+                      <a:solidFill>
+                        <a:srgbClr val="D5DCE6"/>
+                      </a:solidFill>
+                      <a:prstDash val="solid"/>
+                      <a:round/>
+                      <a:headEnd type="none" w="med" len="med"/>
+                      <a:tailEnd type="none" w="med" len="med"/>
+                    </a:lnR>
+                    <a:lnT w="9525" cap="flat" cmpd="sng" algn="ctr">
+                      <a:solidFill>
+                        <a:srgbClr val="D5DCE6"/>
+                      </a:solidFill>
+                      <a:prstDash val="solid"/>
+                      <a:round/>
+                      <a:headEnd type="none" w="med" len="med"/>
+                      <a:tailEnd type="none" w="med" len="med"/>
+                    </a:lnT>
+                    <a:lnB w="9525" cap="flat" cmpd="sng" algn="ctr">
+                      <a:solidFill>
+                        <a:srgbClr val="D5DCE6"/>
+                      </a:solidFill>
+                      <a:prstDash val="solid"/>
+                      <a:round/>
+                      <a:headEnd type="none" w="med" len="med"/>
+                      <a:tailEnd type="none" w="med" len="med"/>
+                    </a:lnB>
+                  </a:tcPr>
+                </a:tc>
+                <a:tc>
+                  <a:txBody>
+                    <a:bodyPr/>
+                    <a:lstStyle/>
+                    <a:p>
+                      <a:pPr algn="r" indent="0" marL="0">
+                        <a:buNone/>
+                      </a:pPr>
+                      <a:r>
+                        <a:rPr lang="en-US" sz="1200" b="1" dirty="0">
+                          <a:solidFill>
+                            <a:srgbClr val="264B82"/>
+                          </a:solidFill>
+                          <a:latin typeface="Inter" pitchFamily="34" charset="0"/>
+                          <a:ea typeface="Inter" pitchFamily="34" charset="-122"/>
+                          <a:cs typeface="Inter" pitchFamily="34" charset="-120"/>
+                        </a:rPr>
+                        <a:t>58</a:t>
+                      </a:r>
+                      <a:endParaRPr lang="en-US" sz="1200" dirty="0">
+                        <a:latin typeface="Inter" charset="0"/>
+                        <a:ea typeface="Inter" charset="0"/>
+                        <a:cs typeface="Inter" charset="0"/>
+                      </a:endParaRPr>
+                    </a:p>
+                  </a:txBody>
+                  <a:tcPr marL="54864" marR="54864" marT="54864" marB="54864" anchor="ctr">
+                    <a:lnL w="9525" cap="flat" cmpd="sng" algn="ctr">
+                      <a:solidFill>
+                        <a:srgbClr val="D5DCE6"/>
+                      </a:solidFill>
+                      <a:prstDash val="solid"/>
+                      <a:round/>
+                      <a:headEnd type="none" w="med" len="med"/>
+                      <a:tailEnd type="none" w="med" len="med"/>
+                    </a:lnL>
+                    <a:lnR w="9525" cap="flat" cmpd="sng" algn="ctr">
+                      <a:solidFill>
+                        <a:srgbClr val="D5DCE6"/>
+                      </a:solidFill>
+                      <a:prstDash val="solid"/>
+                      <a:round/>
+                      <a:headEnd type="none" w="med" len="med"/>
+                      <a:tailEnd type="none" w="med" len="med"/>
+                    </a:lnR>
+                    <a:lnT w="9525" cap="flat" cmpd="sng" algn="ctr">
+                      <a:solidFill>
+                        <a:srgbClr val="D5DCE6"/>
+                      </a:solidFill>
+                      <a:prstDash val="solid"/>
+                      <a:round/>
+                      <a:headEnd type="none" w="med" len="med"/>
+                      <a:tailEnd type="none" w="med" len="med"/>
+                    </a:lnT>
+                    <a:lnB w="9525" cap="flat" cmpd="sng" algn="ctr">
+                      <a:solidFill>
+                        <a:srgbClr val="D5DCE6"/>
+                      </a:solidFill>
+                      <a:prstDash val="solid"/>
+                      <a:round/>
+                      <a:headEnd type="none" w="med" len="med"/>
+                      <a:tailEnd type="none" w="med" len="med"/>
+                    </a:lnB>
+                  </a:tcPr>
+                </a:tc>
+              </a:tr>
+              <a:tr h="301752">
+                <a:tc>
+                  <a:txBody>
+                    <a:bodyPr/>
+                    <a:lstStyle/>
+                    <a:p>
+                      <a:pPr indent="0" marL="0">
+                        <a:buNone/>
+                      </a:pPr>
+                      <a:r>
+                        <a:rPr lang="en-US" sz="1200" dirty="0">
+                          <a:solidFill>
+                            <a:srgbClr val="1F2A3C"/>
+                          </a:solidFill>
+                          <a:latin typeface="Inter" pitchFamily="34" charset="0"/>
+                          <a:ea typeface="Inter" pitchFamily="34" charset="-122"/>
+                          <a:cs typeface="Inter" pitchFamily="34" charset="-120"/>
+                        </a:rPr>
+                        <a:t>Чистая сборка индекса</a:t>
+                      </a:r>
+                      <a:endParaRPr lang="en-US" sz="1200" dirty="0">
+                        <a:latin typeface="Inter" charset="0"/>
+                        <a:ea typeface="Inter" charset="0"/>
+                        <a:cs typeface="Inter" charset="0"/>
+                      </a:endParaRPr>
+                    </a:p>
+                  </a:txBody>
+                  <a:tcPr marL="54864" marR="54864" marT="54864" marB="54864" anchor="ctr">
+                    <a:lnL w="9525" cap="flat" cmpd="sng" algn="ctr">
+                      <a:solidFill>
+                        <a:srgbClr val="D5DCE6"/>
+                      </a:solidFill>
+                      <a:prstDash val="solid"/>
+                      <a:round/>
+                      <a:headEnd type="none" w="med" len="med"/>
+                      <a:tailEnd type="none" w="med" len="med"/>
+                    </a:lnL>
+                    <a:lnR w="9525" cap="flat" cmpd="sng" algn="ctr">
+                      <a:solidFill>
+                        <a:srgbClr val="D5DCE6"/>
+                      </a:solidFill>
+                      <a:prstDash val="solid"/>
+                      <a:round/>
+                      <a:headEnd type="none" w="med" len="med"/>
+                      <a:tailEnd type="none" w="med" len="med"/>
+                    </a:lnR>
+                    <a:lnT w="9525" cap="flat" cmpd="sng" algn="ctr">
+                      <a:solidFill>
+                        <a:srgbClr val="D5DCE6"/>
+                      </a:solidFill>
+                      <a:prstDash val="solid"/>
+                      <a:round/>
+                      <a:headEnd type="none" w="med" len="med"/>
+                      <a:tailEnd type="none" w="med" len="med"/>
+                    </a:lnT>
+                    <a:lnB w="9525" cap="flat" cmpd="sng" algn="ctr">
+                      <a:solidFill>
+                        <a:srgbClr val="D5DCE6"/>
+                      </a:solidFill>
+                      <a:prstDash val="solid"/>
+                      <a:round/>
+                      <a:headEnd type="none" w="med" len="med"/>
+                      <a:tailEnd type="none" w="med" len="med"/>
+                    </a:lnB>
+                  </a:tcPr>
+                </a:tc>
+                <a:tc>
+                  <a:txBody>
+                    <a:bodyPr/>
+                    <a:lstStyle/>
+                    <a:p>
+                      <a:pPr algn="r" indent="0" marL="0">
+                        <a:buNone/>
+                      </a:pPr>
+                      <a:r>
+                        <a:rPr lang="en-US" sz="1200" b="1" dirty="0">
+                          <a:solidFill>
+                            <a:srgbClr val="264B82"/>
+                          </a:solidFill>
+                          <a:latin typeface="Inter" pitchFamily="34" charset="0"/>
+                          <a:ea typeface="Inter" pitchFamily="34" charset="-122"/>
+                          <a:cs typeface="Inter" pitchFamily="34" charset="-120"/>
+                        </a:rPr>
+                        <a:t>~100 с</a:t>
+                      </a:r>
+                      <a:endParaRPr lang="en-US" sz="1200" dirty="0">
+                        <a:latin typeface="Inter" charset="0"/>
+                        <a:ea typeface="Inter" charset="0"/>
+                        <a:cs typeface="Inter" charset="0"/>
+                      </a:endParaRPr>
+                    </a:p>
+                  </a:txBody>
+                  <a:tcPr marL="54864" marR="54864" marT="54864" marB="54864" anchor="ctr">
                     <a:lnL w="9525" cap="flat" cmpd="sng" algn="ctr">
                       <a:solidFill>
                         <a:srgbClr val="D5DCE6"/>
@@ -7514,7 +7910,7 @@
         </p:nvSpPr>
         <p:spPr>
           <a:xfrm>
-            <a:off x="6172200" y="4937760"/>
+            <a:off x="6172200" y="5376672"/>
             <a:ext cx="5257800" cy="228600"/>
           </a:xfrm>
           <a:prstGeom prst="rect">
@@ -7542,7 +7938,7 @@
                 <a:ea typeface="Inter" pitchFamily="34" charset="-122"/>
                 <a:cs typeface="Inter" pitchFamily="34" charset="-120"/>
               </a:rPr>
-              <a:t>Время — замер eval-скрипта qa/run_eval.py</a:t>
+              <a:t>* замер eval-скрипта qa/run_eval.py</a:t>
             </a:r>
             <a:endParaRPr lang="en-US" sz="1100" dirty="0"/>
           </a:p>
@@ -7550,36 +7946,13 @@
       </p:sp>
       <p:sp>
         <p:nvSpPr>
-          <p:cNvPr id="34" name="Shape 31"/>
-          <p:cNvSpPr/>
-          <p:nvPr/>
-        </p:nvSpPr>
-        <p:spPr>
-          <a:xfrm>
-            <a:off x="6172200" y="5257800"/>
-            <a:ext cx="5257800" cy="0"/>
-          </a:xfrm>
-          <a:prstGeom prst="line">
-            <a:avLst/>
-          </a:prstGeom>
-          <a:noFill/>
-          <a:ln w="12700">
-            <a:solidFill>
-              <a:srgbClr val="5AA9F0"/>
-            </a:solidFill>
-            <a:prstDash val="solid"/>
-          </a:ln>
-        </p:spPr>
-      </p:sp>
-      <p:sp>
-        <p:nvSpPr>
-          <p:cNvPr id="35" name="Text 32"/>
-          <p:cNvSpPr txBox="1"/>
-          <p:nvPr/>
-        </p:nvSpPr>
-        <p:spPr>
-          <a:xfrm>
-            <a:off x="6172200" y="5349240"/>
+          <p:cNvPr id="34" name="Text 31"/>
+          <p:cNvSpPr txBox="1"/>
+          <p:nvPr/>
+        </p:nvSpPr>
+        <p:spPr>
+          <a:xfrm>
+            <a:off x="6172200" y="5623560"/>
             <a:ext cx="5257800" cy="274320"/>
           </a:xfrm>
           <a:prstGeom prst="rect">
@@ -7599,7 +7972,7 @@
               <a:buNone/>
             </a:pPr>
             <a:r>
-              <a:rPr lang="en-US" sz="1400" b="1" dirty="0">
+              <a:rPr lang="en-US" sz="1300" b="1" dirty="0">
                 <a:solidFill>
                   <a:srgbClr val="1F2A3C"/>
                 </a:solidFill>
@@ -7609,20 +7982,20 @@
               </a:rPr>
               <a:t>Демо: мебель, одежда, инструменты</a:t>
             </a:r>
-            <a:endParaRPr lang="en-US" sz="1400" dirty="0"/>
-          </a:p>
-        </p:txBody>
-      </p:sp>
-      <p:sp>
-        <p:nvSpPr>
-          <p:cNvPr id="36" name="Text 33"/>
-          <p:cNvSpPr txBox="1"/>
-          <p:nvPr/>
-        </p:nvSpPr>
-        <p:spPr>
-          <a:xfrm>
-            <a:off x="6172200" y="5669280"/>
-            <a:ext cx="5257800" cy="365760"/>
+            <a:endParaRPr lang="en-US" sz="1300" dirty="0"/>
+          </a:p>
+        </p:txBody>
+      </p:sp>
+      <p:sp>
+        <p:nvSpPr>
+          <p:cNvPr id="35" name="Text 32"/>
+          <p:cNvSpPr txBox="1"/>
+          <p:nvPr/>
+        </p:nvSpPr>
+        <p:spPr>
+          <a:xfrm>
+            <a:off x="6172200" y="5897880"/>
+            <a:ext cx="5257800" cy="274320"/>
           </a:xfrm>
           <a:prstGeom prst="rect">
             <a:avLst/>
@@ -7641,7 +8014,7 @@
               <a:buNone/>
             </a:pPr>
             <a:r>
-              <a:rPr lang="en-US" sz="1250" dirty="0">
+              <a:rPr lang="en-US" sz="1200" dirty="0">
                 <a:solidFill>
                   <a:srgbClr val="4A5568"/>
                 </a:solidFill>
@@ -7649,9 +8022,9 @@
                 <a:ea typeface="Inter" pitchFamily="34" charset="-122"/>
                 <a:cs typeface="Inter" pitchFamily="34" charset="-120"/>
               </a:rPr>
-              <a:t>Таблица с бейджами, правка в один клик, воронка N → M → 1.</a:t>
-            </a:r>
-            <a:endParaRPr lang="en-US" sz="1250" dirty="0"/>
+              <a:t>Бейджи, правка в один клик, на выходе группа из 2–3 вариаций.</a:t>
+            </a:r>
+            <a:endParaRPr lang="en-US" sz="1200" dirty="0"/>
           </a:p>
         </p:txBody>
       </p:sp>

</xml_diff>

<commit_message>
docs: final QA numbers in decks and docs (held-out set, injected errors with caveat, p95, pytest 62/62); demo script FU19 counters
</commit_message>
<xml_diff>
--- a/docs/presentation.pptx
+++ b/docs/presentation.pptx
@@ -948,7 +948,7 @@
           <a:p>
             <a:r>
               <a:rPr lang="en-US" dirty="0"/>
-              <a:t>Цифры на текущей версии, эталонные ответы зафиксированы до прогона. Основной набор, 45 кейсов: верный код на первом месте 44/45 — 98%, в тройке — 45/45. Отложенный набор — 45 новых позиций, под которые код не подстраивался: на первом месте 43/45 — 96%, в тройке 44/45 — 98%, статус верный 43/45. По доменам: мебель 15/15, инструменты 15/15, одежда 13/15. Ложных тревог на чистых кейсах — 1/42. Скорость: медиана ~50 мс, p95 99–164 мс по замеру eval-скрипта; 50 параллельных запросов — без ошибок. Справочник — 3391 позиция КТРУ, весь архив; чистая сборка индекса — ~100 с; 58 автотестов pytest. Демо: мебель, одежда, инструменты — от свободного текста до кода КТРУ; показываем таблицу с бейджами и исправление в один клик; на выходе группа из 2–3 вариаций — это нормально, различия задают обязательные характеристики. Если спросят об ограничениях: внесённые ошибки ловятся не все — опечатки и отдельные нереалистичные числа пока пропускаются; проверку несуществующих значений уже добавили.</a:t>
+              <a:t>Цифры на текущей версии: финальный прогон, эталонные ответы зафиксированы до прогона, два прогона совпали. Основной набор, 45 кейсов: верный код на первом месте 44/45 — 98%, в тройке — 45/45, статус верный 45/45. Отложенный набор — 45 новых позиций, под которые код не подстраивался: на первом месте 43/45 — 96%, в тройке 44/45 — 98%, статус верный 43/45. Код первым по категориям: мебель 15/15, инструменты 15/15, одежда 13/15; статус по категориям: мебель 15/15, инструменты 14/15, одежда 14/15. Ложных тревог на чистых кейсах — 1/42, и это H31 — на деле реальная ошибка карточки: лобзик весом 2,1 г. Внесённые ошибки пойманы 30/30: единицы 8/8, нереалистичные числа 8/8, несуществующие значения 7/7, опечатки 7/7 — но набор известен разработчикам — оценка оптимистичная. Скорость: медиана ~50 мс, p95 ~160–190 мс по замеру eval-скрипта; 50 параллельных запросов — без ошибок. Справочник — 3391 позиция КТРУ, весь архив; чистая сборка индекса — ~100 с; автотесты pytest 62/62. Демо: мебель, одежда, инструменты — от свободного текста до кода КТРУ; показываем таблицу с бейджами и исправление в один клик; на выходе группа из 2–3 вариаций — это нормально, различия задают обязательные характеристики. Если спросят об ограничениях: путаем близкие товары (брюки, резиновые сапоги); 30/30 по ошибкам — оптимистичная оценка; одежда — 13/15 на отложенном наборе.</a:t>
             </a:r>
             <a:endParaRPr lang="en-US" dirty="0"/>
           </a:p>
@@ -6091,7 +6091,7 @@
         </p:nvSpPr>
         <p:spPr>
           <a:xfrm>
-            <a:off x="1097280" y="4160520"/>
+            <a:off x="1097280" y="3931920"/>
             <a:ext cx="4480560" cy="228600"/>
           </a:xfrm>
           <a:prstGeom prst="rect">
@@ -6130,8 +6130,8 @@
         </p:nvSpPr>
         <p:spPr>
           <a:xfrm>
-            <a:off x="1097280" y="2697480"/>
-            <a:ext cx="2148840" cy="1325880"/>
+            <a:off x="1097280" y="2670048"/>
+            <a:ext cx="1417320" cy="1143000"/>
           </a:xfrm>
           <a:prstGeom prst="roundRect">
             <a:avLst>
@@ -6152,8 +6152,8 @@
         </p:nvSpPr>
         <p:spPr>
           <a:xfrm>
-            <a:off x="1188720" y="2862072"/>
-            <a:ext cx="1965960" cy="548640"/>
+            <a:off x="1143000" y="2788920"/>
+            <a:ext cx="1325880" cy="411480"/>
           </a:xfrm>
           <a:prstGeom prst="rect">
             <a:avLst/>
@@ -6172,7 +6172,7 @@
               <a:buNone/>
             </a:pPr>
             <a:r>
-              <a:rPr lang="en-US" sz="3400" b="1" dirty="0">
+              <a:rPr lang="en-US" sz="2600" b="1" dirty="0">
                 <a:solidFill>
                   <a:srgbClr val="1E88E5"/>
                 </a:solidFill>
@@ -6182,7 +6182,7 @@
               </a:rPr>
               <a:t>98%</a:t>
             </a:r>
-            <a:endParaRPr lang="en-US" sz="3400" dirty="0"/>
+            <a:endParaRPr lang="en-US" sz="2600" dirty="0"/>
           </a:p>
         </p:txBody>
       </p:sp>
@@ -6194,8 +6194,8 @@
         </p:nvSpPr>
         <p:spPr>
           <a:xfrm>
-            <a:off x="1188720" y="3502152"/>
-            <a:ext cx="1965960" cy="365760"/>
+            <a:off x="1143000" y="3255264"/>
+            <a:ext cx="1325880" cy="502920"/>
           </a:xfrm>
           <a:prstGeom prst="rect">
             <a:avLst/>
@@ -6209,12 +6209,12 @@
           <a:p>
             <a:pPr algn="ctr" indent="0" marL="0">
               <a:lnSpc>
-                <a:spcPct val="115000"/>
+                <a:spcPct val="105000"/>
               </a:lnSpc>
               <a:buNone/>
             </a:pPr>
             <a:r>
-              <a:rPr lang="en-US" sz="1200" dirty="0">
+              <a:rPr lang="en-US" sz="1150" dirty="0">
                 <a:solidFill>
                   <a:srgbClr val="4A5568"/>
                 </a:solidFill>
@@ -6222,9 +6222,29 @@
                 <a:ea typeface="Inter" pitchFamily="34" charset="-122"/>
                 <a:cs typeface="Inter" pitchFamily="34" charset="-120"/>
               </a:rPr>
-              <a:t>код на 1-м месте · 44/45</a:t>
-            </a:r>
-            <a:endParaRPr lang="en-US" sz="1200" dirty="0"/>
+              <a:t>код 1-й</a:t>
+            </a:r>
+            <a:endParaRPr lang="en-US" sz="1150" dirty="0"/>
+          </a:p>
+          <a:p>
+            <a:pPr algn="ctr" indent="0" marL="0">
+              <a:lnSpc>
+                <a:spcPct val="105000"/>
+              </a:lnSpc>
+              <a:buNone/>
+            </a:pPr>
+            <a:r>
+              <a:rPr lang="en-US" sz="1150" dirty="0">
+                <a:solidFill>
+                  <a:srgbClr val="4A5568"/>
+                </a:solidFill>
+                <a:latin typeface="Inter" pitchFamily="34" charset="0"/>
+                <a:ea typeface="Inter" pitchFamily="34" charset="-122"/>
+                <a:cs typeface="Inter" pitchFamily="34" charset="-120"/>
+              </a:rPr>
+              <a:t>44/45</a:t>
+            </a:r>
+            <a:endParaRPr lang="en-US" sz="1150" dirty="0"/>
           </a:p>
         </p:txBody>
       </p:sp>
@@ -6236,8 +6256,8 @@
         </p:nvSpPr>
         <p:spPr>
           <a:xfrm>
-            <a:off x="3383280" y="2697480"/>
-            <a:ext cx="2148840" cy="1325880"/>
+            <a:off x="2606040" y="2670048"/>
+            <a:ext cx="1417320" cy="1143000"/>
           </a:xfrm>
           <a:prstGeom prst="roundRect">
             <a:avLst>
@@ -6258,8 +6278,8 @@
         </p:nvSpPr>
         <p:spPr>
           <a:xfrm>
-            <a:off x="3474720" y="2862072"/>
-            <a:ext cx="1965960" cy="548640"/>
+            <a:off x="2651760" y="2788920"/>
+            <a:ext cx="1325880" cy="411480"/>
           </a:xfrm>
           <a:prstGeom prst="rect">
             <a:avLst/>
@@ -6278,7 +6298,7 @@
               <a:buNone/>
             </a:pPr>
             <a:r>
-              <a:rPr lang="en-US" sz="3400" b="1" dirty="0">
+              <a:rPr lang="en-US" sz="2600" b="1" dirty="0">
                 <a:solidFill>
                   <a:srgbClr val="1E88E5"/>
                 </a:solidFill>
@@ -6288,7 +6308,7 @@
               </a:rPr>
               <a:t>100%</a:t>
             </a:r>
-            <a:endParaRPr lang="en-US" sz="3400" dirty="0"/>
+            <a:endParaRPr lang="en-US" sz="2600" dirty="0"/>
           </a:p>
         </p:txBody>
       </p:sp>
@@ -6300,8 +6320,8 @@
         </p:nvSpPr>
         <p:spPr>
           <a:xfrm>
-            <a:off x="3474720" y="3502152"/>
-            <a:ext cx="1965960" cy="365760"/>
+            <a:off x="2651760" y="3255264"/>
+            <a:ext cx="1325880" cy="502920"/>
           </a:xfrm>
           <a:prstGeom prst="rect">
             <a:avLst/>
@@ -6315,12 +6335,12 @@
           <a:p>
             <a:pPr algn="ctr" indent="0" marL="0">
               <a:lnSpc>
-                <a:spcPct val="115000"/>
+                <a:spcPct val="105000"/>
               </a:lnSpc>
               <a:buNone/>
             </a:pPr>
             <a:r>
-              <a:rPr lang="en-US" sz="1200" dirty="0">
+              <a:rPr lang="en-US" sz="1150" dirty="0">
                 <a:solidFill>
                   <a:srgbClr val="4A5568"/>
                 </a:solidFill>
@@ -6328,9 +6348,29 @@
                 <a:ea typeface="Inter" pitchFamily="34" charset="-122"/>
                 <a:cs typeface="Inter" pitchFamily="34" charset="-120"/>
               </a:rPr>
-              <a:t>код в топ-3 · 45/45</a:t>
-            </a:r>
-            <a:endParaRPr lang="en-US" sz="1200" dirty="0"/>
+              <a:t>код в топ-3</a:t>
+            </a:r>
+            <a:endParaRPr lang="en-US" sz="1150" dirty="0"/>
+          </a:p>
+          <a:p>
+            <a:pPr algn="ctr" indent="0" marL="0">
+              <a:lnSpc>
+                <a:spcPct val="105000"/>
+              </a:lnSpc>
+              <a:buNone/>
+            </a:pPr>
+            <a:r>
+              <a:rPr lang="en-US" sz="1150" dirty="0">
+                <a:solidFill>
+                  <a:srgbClr val="4A5568"/>
+                </a:solidFill>
+                <a:latin typeface="Inter" pitchFamily="34" charset="0"/>
+                <a:ea typeface="Inter" pitchFamily="34" charset="-122"/>
+                <a:cs typeface="Inter" pitchFamily="34" charset="-120"/>
+              </a:rPr>
+              <a:t>45/45</a:t>
+            </a:r>
+            <a:endParaRPr lang="en-US" sz="1150" dirty="0"/>
           </a:p>
         </p:txBody>
       </p:sp>
@@ -6342,8 +6382,8 @@
         </p:nvSpPr>
         <p:spPr>
           <a:xfrm>
-            <a:off x="1097280" y="4462272"/>
-            <a:ext cx="2148840" cy="1325880"/>
+            <a:off x="4114800" y="2670048"/>
+            <a:ext cx="1417320" cy="1143000"/>
           </a:xfrm>
           <a:prstGeom prst="roundRect">
             <a:avLst>
@@ -6364,8 +6404,8 @@
         </p:nvSpPr>
         <p:spPr>
           <a:xfrm>
-            <a:off x="1188720" y="4626864"/>
-            <a:ext cx="1965960" cy="548640"/>
+            <a:off x="4160520" y="2788920"/>
+            <a:ext cx="1325880" cy="411480"/>
           </a:xfrm>
           <a:prstGeom prst="rect">
             <a:avLst/>
@@ -6384,7 +6424,7 @@
               <a:buNone/>
             </a:pPr>
             <a:r>
-              <a:rPr lang="en-US" sz="3400" b="1" dirty="0">
+              <a:rPr lang="en-US" sz="2600" b="1" dirty="0">
                 <a:solidFill>
                   <a:srgbClr val="1E88E5"/>
                 </a:solidFill>
@@ -6392,9 +6432,9 @@
                 <a:ea typeface="Inter" pitchFamily="34" charset="-122"/>
                 <a:cs typeface="Inter" pitchFamily="34" charset="-120"/>
               </a:rPr>
-              <a:t>96%</a:t>
-            </a:r>
-            <a:endParaRPr lang="en-US" sz="3400" dirty="0"/>
+              <a:t>100%</a:t>
+            </a:r>
+            <a:endParaRPr lang="en-US" sz="2600" dirty="0"/>
           </a:p>
         </p:txBody>
       </p:sp>
@@ -6406,8 +6446,8 @@
         </p:nvSpPr>
         <p:spPr>
           <a:xfrm>
-            <a:off x="1188720" y="5266944"/>
-            <a:ext cx="1965960" cy="365760"/>
+            <a:off x="4160520" y="3255264"/>
+            <a:ext cx="1325880" cy="502920"/>
           </a:xfrm>
           <a:prstGeom prst="rect">
             <a:avLst/>
@@ -6421,12 +6461,12 @@
           <a:p>
             <a:pPr algn="ctr" indent="0" marL="0">
               <a:lnSpc>
-                <a:spcPct val="115000"/>
+                <a:spcPct val="105000"/>
               </a:lnSpc>
               <a:buNone/>
             </a:pPr>
             <a:r>
-              <a:rPr lang="en-US" sz="1200" dirty="0">
+              <a:rPr lang="en-US" sz="1150" dirty="0">
                 <a:solidFill>
                   <a:srgbClr val="4A5568"/>
                 </a:solidFill>
@@ -6434,9 +6474,29 @@
                 <a:ea typeface="Inter" pitchFamily="34" charset="-122"/>
                 <a:cs typeface="Inter" pitchFamily="34" charset="-120"/>
               </a:rPr>
-              <a:t>код на 1-м месте · 43/45</a:t>
-            </a:r>
-            <a:endParaRPr lang="en-US" sz="1200" dirty="0"/>
+              <a:t>статус</a:t>
+            </a:r>
+            <a:endParaRPr lang="en-US" sz="1150" dirty="0"/>
+          </a:p>
+          <a:p>
+            <a:pPr algn="ctr" indent="0" marL="0">
+              <a:lnSpc>
+                <a:spcPct val="105000"/>
+              </a:lnSpc>
+              <a:buNone/>
+            </a:pPr>
+            <a:r>
+              <a:rPr lang="en-US" sz="1150" dirty="0">
+                <a:solidFill>
+                  <a:srgbClr val="4A5568"/>
+                </a:solidFill>
+                <a:latin typeface="Inter" pitchFamily="34" charset="0"/>
+                <a:ea typeface="Inter" pitchFamily="34" charset="-122"/>
+                <a:cs typeface="Inter" pitchFamily="34" charset="-120"/>
+              </a:rPr>
+              <a:t>45/45</a:t>
+            </a:r>
+            <a:endParaRPr lang="en-US" sz="1150" dirty="0"/>
           </a:p>
         </p:txBody>
       </p:sp>
@@ -6448,8 +6508,8 @@
         </p:nvSpPr>
         <p:spPr>
           <a:xfrm>
-            <a:off x="3383280" y="4462272"/>
-            <a:ext cx="2148840" cy="1325880"/>
+            <a:off x="1097280" y="4187952"/>
+            <a:ext cx="1417320" cy="1143000"/>
           </a:xfrm>
           <a:prstGeom prst="roundRect">
             <a:avLst>
@@ -6470,8 +6530,8 @@
         </p:nvSpPr>
         <p:spPr>
           <a:xfrm>
-            <a:off x="3474720" y="4626864"/>
-            <a:ext cx="1965960" cy="548640"/>
+            <a:off x="1143000" y="4306824"/>
+            <a:ext cx="1325880" cy="411480"/>
           </a:xfrm>
           <a:prstGeom prst="rect">
             <a:avLst/>
@@ -6490,7 +6550,7 @@
               <a:buNone/>
             </a:pPr>
             <a:r>
-              <a:rPr lang="en-US" sz="3400" b="1" dirty="0">
+              <a:rPr lang="en-US" sz="2600" b="1" dirty="0">
                 <a:solidFill>
                   <a:srgbClr val="1E88E5"/>
                 </a:solidFill>
@@ -6498,22 +6558,148 @@
                 <a:ea typeface="Inter" pitchFamily="34" charset="-122"/>
                 <a:cs typeface="Inter" pitchFamily="34" charset="-120"/>
               </a:rPr>
+              <a:t>96%</a:t>
+            </a:r>
+            <a:endParaRPr lang="en-US" sz="2600" dirty="0"/>
+          </a:p>
+        </p:txBody>
+      </p:sp>
+      <p:sp>
+        <p:nvSpPr>
+          <p:cNvPr id="31" name="Text 29"/>
+          <p:cNvSpPr txBox="1"/>
+          <p:nvPr/>
+        </p:nvSpPr>
+        <p:spPr>
+          <a:xfrm>
+            <a:off x="1143000" y="4773168"/>
+            <a:ext cx="1325880" cy="502920"/>
+          </a:xfrm>
+          <a:prstGeom prst="rect">
+            <a:avLst/>
+          </a:prstGeom>
+          <a:noFill/>
+          <a:ln/>
+        </p:spPr>
+        <p:txBody>
+          <a:bodyPr wrap="square" lIns="0" tIns="0" rIns="0" bIns="0" rtlCol="0" anchor="t"/>
+          <a:lstStyle/>
+          <a:p>
+            <a:pPr algn="ctr" indent="0" marL="0">
+              <a:lnSpc>
+                <a:spcPct val="105000"/>
+              </a:lnSpc>
+              <a:buNone/>
+            </a:pPr>
+            <a:r>
+              <a:rPr lang="en-US" sz="1150" dirty="0">
+                <a:solidFill>
+                  <a:srgbClr val="4A5568"/>
+                </a:solidFill>
+                <a:latin typeface="Inter" pitchFamily="34" charset="0"/>
+                <a:ea typeface="Inter" pitchFamily="34" charset="-122"/>
+                <a:cs typeface="Inter" pitchFamily="34" charset="-120"/>
+              </a:rPr>
+              <a:t>код 1-й</a:t>
+            </a:r>
+            <a:endParaRPr lang="en-US" sz="1150" dirty="0"/>
+          </a:p>
+          <a:p>
+            <a:pPr algn="ctr" indent="0" marL="0">
+              <a:lnSpc>
+                <a:spcPct val="105000"/>
+              </a:lnSpc>
+              <a:buNone/>
+            </a:pPr>
+            <a:r>
+              <a:rPr lang="en-US" sz="1150" dirty="0">
+                <a:solidFill>
+                  <a:srgbClr val="4A5568"/>
+                </a:solidFill>
+                <a:latin typeface="Inter" pitchFamily="34" charset="0"/>
+                <a:ea typeface="Inter" pitchFamily="34" charset="-122"/>
+                <a:cs typeface="Inter" pitchFamily="34" charset="-120"/>
+              </a:rPr>
+              <a:t>43/45</a:t>
+            </a:r>
+            <a:endParaRPr lang="en-US" sz="1150" dirty="0"/>
+          </a:p>
+        </p:txBody>
+      </p:sp>
+      <p:sp>
+        <p:nvSpPr>
+          <p:cNvPr id="32" name="Shape 30"/>
+          <p:cNvSpPr/>
+          <p:nvPr/>
+        </p:nvSpPr>
+        <p:spPr>
+          <a:xfrm>
+            <a:off x="2606040" y="4187952"/>
+            <a:ext cx="1417320" cy="1143000"/>
+          </a:xfrm>
+          <a:prstGeom prst="roundRect">
+            <a:avLst>
+              <a:gd name="adj" fmla="val 10000"/>
+            </a:avLst>
+          </a:prstGeom>
+          <a:solidFill>
+            <a:srgbClr val="FFFFFF"/>
+          </a:solidFill>
+          <a:ln/>
+        </p:spPr>
+      </p:sp>
+      <p:sp>
+        <p:nvSpPr>
+          <p:cNvPr id="33" name="Text 31"/>
+          <p:cNvSpPr txBox="1"/>
+          <p:nvPr/>
+        </p:nvSpPr>
+        <p:spPr>
+          <a:xfrm>
+            <a:off x="2651760" y="4306824"/>
+            <a:ext cx="1325880" cy="411480"/>
+          </a:xfrm>
+          <a:prstGeom prst="rect">
+            <a:avLst/>
+          </a:prstGeom>
+          <a:noFill/>
+          <a:ln/>
+        </p:spPr>
+        <p:txBody>
+          <a:bodyPr wrap="square" lIns="0" tIns="0" rIns="0" bIns="0" rtlCol="0" anchor="t"/>
+          <a:lstStyle/>
+          <a:p>
+            <a:pPr algn="ctr" indent="0" marL="0">
+              <a:lnSpc>
+                <a:spcPct val="95000"/>
+              </a:lnSpc>
+              <a:buNone/>
+            </a:pPr>
+            <a:r>
+              <a:rPr lang="en-US" sz="2600" b="1" dirty="0">
+                <a:solidFill>
+                  <a:srgbClr val="1E88E5"/>
+                </a:solidFill>
+                <a:latin typeface="Inter" pitchFamily="34" charset="0"/>
+                <a:ea typeface="Inter" pitchFamily="34" charset="-122"/>
+                <a:cs typeface="Inter" pitchFamily="34" charset="-120"/>
+              </a:rPr>
               <a:t>98%</a:t>
             </a:r>
-            <a:endParaRPr lang="en-US" sz="3400" dirty="0"/>
-          </a:p>
-        </p:txBody>
-      </p:sp>
-      <p:sp>
-        <p:nvSpPr>
-          <p:cNvPr id="31" name="Text 29"/>
-          <p:cNvSpPr txBox="1"/>
-          <p:nvPr/>
-        </p:nvSpPr>
-        <p:spPr>
-          <a:xfrm>
-            <a:off x="3474720" y="5266944"/>
-            <a:ext cx="1965960" cy="365760"/>
+            <a:endParaRPr lang="en-US" sz="2600" dirty="0"/>
+          </a:p>
+        </p:txBody>
+      </p:sp>
+      <p:sp>
+        <p:nvSpPr>
+          <p:cNvPr id="34" name="Text 32"/>
+          <p:cNvSpPr txBox="1"/>
+          <p:nvPr/>
+        </p:nvSpPr>
+        <p:spPr>
+          <a:xfrm>
+            <a:off x="2651760" y="4773168"/>
+            <a:ext cx="1325880" cy="502920"/>
           </a:xfrm>
           <a:prstGeom prst="rect">
             <a:avLst/>
@@ -6526,13 +6712,221 @@
           <a:lstStyle/>
           <a:p>
             <a:pPr algn="ctr" indent="0" marL="0">
+              <a:lnSpc>
+                <a:spcPct val="105000"/>
+              </a:lnSpc>
+              <a:buNone/>
+            </a:pPr>
+            <a:r>
+              <a:rPr lang="en-US" sz="1150" dirty="0">
+                <a:solidFill>
+                  <a:srgbClr val="4A5568"/>
+                </a:solidFill>
+                <a:latin typeface="Inter" pitchFamily="34" charset="0"/>
+                <a:ea typeface="Inter" pitchFamily="34" charset="-122"/>
+                <a:cs typeface="Inter" pitchFamily="34" charset="-120"/>
+              </a:rPr>
+              <a:t>код в топ-3</a:t>
+            </a:r>
+            <a:endParaRPr lang="en-US" sz="1150" dirty="0"/>
+          </a:p>
+          <a:p>
+            <a:pPr algn="ctr" indent="0" marL="0">
+              <a:lnSpc>
+                <a:spcPct val="105000"/>
+              </a:lnSpc>
+              <a:buNone/>
+            </a:pPr>
+            <a:r>
+              <a:rPr lang="en-US" sz="1150" dirty="0">
+                <a:solidFill>
+                  <a:srgbClr val="4A5568"/>
+                </a:solidFill>
+                <a:latin typeface="Inter" pitchFamily="34" charset="0"/>
+                <a:ea typeface="Inter" pitchFamily="34" charset="-122"/>
+                <a:cs typeface="Inter" pitchFamily="34" charset="-120"/>
+              </a:rPr>
+              <a:t>44/45</a:t>
+            </a:r>
+            <a:endParaRPr lang="en-US" sz="1150" dirty="0"/>
+          </a:p>
+        </p:txBody>
+      </p:sp>
+      <p:sp>
+        <p:nvSpPr>
+          <p:cNvPr id="35" name="Shape 33"/>
+          <p:cNvSpPr/>
+          <p:nvPr/>
+        </p:nvSpPr>
+        <p:spPr>
+          <a:xfrm>
+            <a:off x="4114800" y="4187952"/>
+            <a:ext cx="1417320" cy="1143000"/>
+          </a:xfrm>
+          <a:prstGeom prst="roundRect">
+            <a:avLst>
+              <a:gd name="adj" fmla="val 10000"/>
+            </a:avLst>
+          </a:prstGeom>
+          <a:solidFill>
+            <a:srgbClr val="FFFFFF"/>
+          </a:solidFill>
+          <a:ln/>
+        </p:spPr>
+      </p:sp>
+      <p:sp>
+        <p:nvSpPr>
+          <p:cNvPr id="36" name="Text 34"/>
+          <p:cNvSpPr txBox="1"/>
+          <p:nvPr/>
+        </p:nvSpPr>
+        <p:spPr>
+          <a:xfrm>
+            <a:off x="4160520" y="4306824"/>
+            <a:ext cx="1325880" cy="411480"/>
+          </a:xfrm>
+          <a:prstGeom prst="rect">
+            <a:avLst/>
+          </a:prstGeom>
+          <a:noFill/>
+          <a:ln/>
+        </p:spPr>
+        <p:txBody>
+          <a:bodyPr wrap="square" lIns="0" tIns="0" rIns="0" bIns="0" rtlCol="0" anchor="t"/>
+          <a:lstStyle/>
+          <a:p>
+            <a:pPr algn="ctr" indent="0" marL="0">
+              <a:lnSpc>
+                <a:spcPct val="95000"/>
+              </a:lnSpc>
+              <a:buNone/>
+            </a:pPr>
+            <a:r>
+              <a:rPr lang="en-US" sz="2600" b="1" dirty="0">
+                <a:solidFill>
+                  <a:srgbClr val="1E88E5"/>
+                </a:solidFill>
+                <a:latin typeface="Inter" pitchFamily="34" charset="0"/>
+                <a:ea typeface="Inter" pitchFamily="34" charset="-122"/>
+                <a:cs typeface="Inter" pitchFamily="34" charset="-120"/>
+              </a:rPr>
+              <a:t>96%</a:t>
+            </a:r>
+            <a:endParaRPr lang="en-US" sz="2600" dirty="0"/>
+          </a:p>
+        </p:txBody>
+      </p:sp>
+      <p:sp>
+        <p:nvSpPr>
+          <p:cNvPr id="37" name="Text 35"/>
+          <p:cNvSpPr txBox="1"/>
+          <p:nvPr/>
+        </p:nvSpPr>
+        <p:spPr>
+          <a:xfrm>
+            <a:off x="4160520" y="4773168"/>
+            <a:ext cx="1325880" cy="502920"/>
+          </a:xfrm>
+          <a:prstGeom prst="rect">
+            <a:avLst/>
+          </a:prstGeom>
+          <a:noFill/>
+          <a:ln/>
+        </p:spPr>
+        <p:txBody>
+          <a:bodyPr wrap="square" lIns="0" tIns="0" rIns="0" bIns="0" rtlCol="0" anchor="t"/>
+          <a:lstStyle/>
+          <a:p>
+            <a:pPr algn="ctr" indent="0" marL="0">
+              <a:lnSpc>
+                <a:spcPct val="105000"/>
+              </a:lnSpc>
+              <a:buNone/>
+            </a:pPr>
+            <a:r>
+              <a:rPr lang="en-US" sz="1150" dirty="0">
+                <a:solidFill>
+                  <a:srgbClr val="4A5568"/>
+                </a:solidFill>
+                <a:latin typeface="Inter" pitchFamily="34" charset="0"/>
+                <a:ea typeface="Inter" pitchFamily="34" charset="-122"/>
+                <a:cs typeface="Inter" pitchFamily="34" charset="-120"/>
+              </a:rPr>
+              <a:t>статус</a:t>
+            </a:r>
+            <a:endParaRPr lang="en-US" sz="1150" dirty="0"/>
+          </a:p>
+          <a:p>
+            <a:pPr algn="ctr" indent="0" marL="0">
+              <a:lnSpc>
+                <a:spcPct val="105000"/>
+              </a:lnSpc>
+              <a:buNone/>
+            </a:pPr>
+            <a:r>
+              <a:rPr lang="en-US" sz="1150" dirty="0">
+                <a:solidFill>
+                  <a:srgbClr val="4A5568"/>
+                </a:solidFill>
+                <a:latin typeface="Inter" pitchFamily="34" charset="0"/>
+                <a:ea typeface="Inter" pitchFamily="34" charset="-122"/>
+                <a:cs typeface="Inter" pitchFamily="34" charset="-120"/>
+              </a:rPr>
+              <a:t>43/45</a:t>
+            </a:r>
+            <a:endParaRPr lang="en-US" sz="1150" dirty="0"/>
+          </a:p>
+        </p:txBody>
+      </p:sp>
+      <p:sp>
+        <p:nvSpPr>
+          <p:cNvPr id="38" name="Text 36"/>
+          <p:cNvSpPr txBox="1"/>
+          <p:nvPr/>
+        </p:nvSpPr>
+        <p:spPr>
+          <a:xfrm>
+            <a:off x="1097280" y="5413248"/>
+            <a:ext cx="4480560" cy="502920"/>
+          </a:xfrm>
+          <a:prstGeom prst="rect">
+            <a:avLst/>
+          </a:prstGeom>
+          <a:noFill/>
+          <a:ln/>
+        </p:spPr>
+        <p:txBody>
+          <a:bodyPr wrap="square" lIns="0" tIns="0" rIns="0" bIns="0" rtlCol="0" anchor="t"/>
+          <a:lstStyle/>
+          <a:p>
+            <a:pPr indent="0" marL="0">
               <a:lnSpc>
                 <a:spcPct val="115000"/>
               </a:lnSpc>
               <a:buNone/>
             </a:pPr>
             <a:r>
-              <a:rPr lang="en-US" sz="1200" dirty="0">
+              <a:rPr lang="en-US" sz="1150" b="1" dirty="0">
+                <a:solidFill>
+                  <a:srgbClr val="1F2A3C"/>
+                </a:solidFill>
+                <a:latin typeface="Inter" pitchFamily="34" charset="0"/>
+                <a:ea typeface="Inter" pitchFamily="34" charset="-122"/>
+                <a:cs typeface="Inter" pitchFamily="34" charset="-120"/>
+              </a:rPr>
+              <a:t>Код первым по категориям:</a:t>
+            </a:r>
+            <a:endParaRPr lang="en-US" sz="1150" dirty="0"/>
+          </a:p>
+          <a:p>
+            <a:pPr indent="0" marL="0">
+              <a:lnSpc>
+                <a:spcPct val="115000"/>
+              </a:lnSpc>
+              <a:buNone/>
+            </a:pPr>
+            <a:r>
+              <a:rPr lang="en-US" sz="1150" dirty="0">
                 <a:solidFill>
                   <a:srgbClr val="4A5568"/>
                 </a:solidFill>
@@ -6540,15 +6934,15 @@
                 <a:ea typeface="Inter" pitchFamily="34" charset="-122"/>
                 <a:cs typeface="Inter" pitchFamily="34" charset="-120"/>
               </a:rPr>
-              <a:t>код в топ-3 · 44/45</a:t>
-            </a:r>
-            <a:endParaRPr lang="en-US" sz="1200" dirty="0"/>
+              <a:t>мебель 15/15 · инструменты 15/15 · одежда 13/15</a:t>
+            </a:r>
+            <a:endParaRPr lang="en-US" sz="1150" dirty="0"/>
           </a:p>
         </p:txBody>
       </p:sp>
       <p:graphicFrame>
         <p:nvGraphicFramePr>
-          <p:cNvPr id="36" name="Table 0"/>
+          <p:cNvPr id="43" name="Table 0"/>
           <p:cNvGraphicFramePr>
             <a:graphicFrameLocks noGrp="1"/>
           </p:cNvGraphicFramePr>
@@ -6569,8 +6963,8 @@
             <a:tbl>
               <a:tblPr/>
               <a:tblGrid>
-                <a:gridCol w="3017520"/>
-                <a:gridCol w="2240280"/>
+                <a:gridCol w="2971800"/>
+                <a:gridCol w="2286000"/>
               </a:tblGrid>
               <a:tr h="301752">
                 <a:tc>
@@ -6728,7 +7122,7 @@
                           <a:ea typeface="Inter" pitchFamily="34" charset="-122"/>
                           <a:cs typeface="Inter" pitchFamily="34" charset="-120"/>
                         </a:rPr>
-                        <a:t>Статус верный (отложенный)</a:t>
+                        <a:t>Внесённые ошибки пойманы**</a:t>
                       </a:r>
                       <a:endParaRPr lang="en-US" sz="1200" dirty="0">
                         <a:latin typeface="Inter" charset="0"/>
@@ -6793,7 +7187,7 @@
                           <a:ea typeface="Inter" pitchFamily="34" charset="-122"/>
                           <a:cs typeface="Inter" pitchFamily="34" charset="-120"/>
                         </a:rPr>
-                        <a:t>43/45 · 96%</a:t>
+                        <a:t>30/30</a:t>
                       </a:r>
                       <a:endParaRPr lang="en-US" sz="1200" dirty="0">
                         <a:latin typeface="Inter" charset="0"/>
@@ -6860,7 +7254,7 @@
                           <a:ea typeface="Inter" pitchFamily="34" charset="-122"/>
                           <a:cs typeface="Inter" pitchFamily="34" charset="-120"/>
                         </a:rPr>
-                        <a:t>Мебель / инструменты / одежда</a:t>
+                        <a:t>Время ответа: медиана / p95*</a:t>
                       </a:r>
                       <a:endParaRPr lang="en-US" sz="1200" dirty="0">
                         <a:latin typeface="Inter" charset="0"/>
@@ -6925,403 +7319,7 @@
                           <a:ea typeface="Inter" pitchFamily="34" charset="-122"/>
                           <a:cs typeface="Inter" pitchFamily="34" charset="-120"/>
                         </a:rPr>
-                        <a:t>15/15 · 15/15 · 13/15</a:t>
-                      </a:r>
-                      <a:endParaRPr lang="en-US" sz="1200" dirty="0">
-                        <a:latin typeface="Inter" charset="0"/>
-                        <a:ea typeface="Inter" charset="0"/>
-                        <a:cs typeface="Inter" charset="0"/>
-                      </a:endParaRPr>
-                    </a:p>
-                  </a:txBody>
-                  <a:tcPr marL="54864" marR="54864" marT="54864" marB="54864" anchor="ctr">
-                    <a:lnL w="9525" cap="flat" cmpd="sng" algn="ctr">
-                      <a:solidFill>
-                        <a:srgbClr val="D5DCE6"/>
-                      </a:solidFill>
-                      <a:prstDash val="solid"/>
-                      <a:round/>
-                      <a:headEnd type="none" w="med" len="med"/>
-                      <a:tailEnd type="none" w="med" len="med"/>
-                    </a:lnL>
-                    <a:lnR w="9525" cap="flat" cmpd="sng" algn="ctr">
-                      <a:solidFill>
-                        <a:srgbClr val="D5DCE6"/>
-                      </a:solidFill>
-                      <a:prstDash val="solid"/>
-                      <a:round/>
-                      <a:headEnd type="none" w="med" len="med"/>
-                      <a:tailEnd type="none" w="med" len="med"/>
-                    </a:lnR>
-                    <a:lnT w="9525" cap="flat" cmpd="sng" algn="ctr">
-                      <a:solidFill>
-                        <a:srgbClr val="D5DCE6"/>
-                      </a:solidFill>
-                      <a:prstDash val="solid"/>
-                      <a:round/>
-                      <a:headEnd type="none" w="med" len="med"/>
-                      <a:tailEnd type="none" w="med" len="med"/>
-                    </a:lnT>
-                    <a:lnB w="9525" cap="flat" cmpd="sng" algn="ctr">
-                      <a:solidFill>
-                        <a:srgbClr val="D5DCE6"/>
-                      </a:solidFill>
-                      <a:prstDash val="solid"/>
-                      <a:round/>
-                      <a:headEnd type="none" w="med" len="med"/>
-                      <a:tailEnd type="none" w="med" len="med"/>
-                    </a:lnB>
-                  </a:tcPr>
-                </a:tc>
-              </a:tr>
-              <a:tr h="301752">
-                <a:tc>
-                  <a:txBody>
-                    <a:bodyPr/>
-                    <a:lstStyle/>
-                    <a:p>
-                      <a:pPr indent="0" marL="0">
-                        <a:buNone/>
-                      </a:pPr>
-                      <a:r>
-                        <a:rPr lang="en-US" sz="1200" dirty="0">
-                          <a:solidFill>
-                            <a:srgbClr val="1F2A3C"/>
-                          </a:solidFill>
-                          <a:latin typeface="Inter" pitchFamily="34" charset="0"/>
-                          <a:ea typeface="Inter" pitchFamily="34" charset="-122"/>
-                          <a:cs typeface="Inter" pitchFamily="34" charset="-120"/>
-                        </a:rPr>
-                        <a:t>Ложные тревоги на чистых</a:t>
-                      </a:r>
-                      <a:endParaRPr lang="en-US" sz="1200" dirty="0">
-                        <a:latin typeface="Inter" charset="0"/>
-                        <a:ea typeface="Inter" charset="0"/>
-                        <a:cs typeface="Inter" charset="0"/>
-                      </a:endParaRPr>
-                    </a:p>
-                  </a:txBody>
-                  <a:tcPr marL="54864" marR="54864" marT="54864" marB="54864" anchor="ctr">
-                    <a:lnL w="9525" cap="flat" cmpd="sng" algn="ctr">
-                      <a:solidFill>
-                        <a:srgbClr val="D5DCE6"/>
-                      </a:solidFill>
-                      <a:prstDash val="solid"/>
-                      <a:round/>
-                      <a:headEnd type="none" w="med" len="med"/>
-                      <a:tailEnd type="none" w="med" len="med"/>
-                    </a:lnL>
-                    <a:lnR w="9525" cap="flat" cmpd="sng" algn="ctr">
-                      <a:solidFill>
-                        <a:srgbClr val="D5DCE6"/>
-                      </a:solidFill>
-                      <a:prstDash val="solid"/>
-                      <a:round/>
-                      <a:headEnd type="none" w="med" len="med"/>
-                      <a:tailEnd type="none" w="med" len="med"/>
-                    </a:lnR>
-                    <a:lnT w="9525" cap="flat" cmpd="sng" algn="ctr">
-                      <a:solidFill>
-                        <a:srgbClr val="D5DCE6"/>
-                      </a:solidFill>
-                      <a:prstDash val="solid"/>
-                      <a:round/>
-                      <a:headEnd type="none" w="med" len="med"/>
-                      <a:tailEnd type="none" w="med" len="med"/>
-                    </a:lnT>
-                    <a:lnB w="9525" cap="flat" cmpd="sng" algn="ctr">
-                      <a:solidFill>
-                        <a:srgbClr val="D5DCE6"/>
-                      </a:solidFill>
-                      <a:prstDash val="solid"/>
-                      <a:round/>
-                      <a:headEnd type="none" w="med" len="med"/>
-                      <a:tailEnd type="none" w="med" len="med"/>
-                    </a:lnB>
-                  </a:tcPr>
-                </a:tc>
-                <a:tc>
-                  <a:txBody>
-                    <a:bodyPr/>
-                    <a:lstStyle/>
-                    <a:p>
-                      <a:pPr algn="r" indent="0" marL="0">
-                        <a:buNone/>
-                      </a:pPr>
-                      <a:r>
-                        <a:rPr lang="en-US" sz="1200" b="1" dirty="0">
-                          <a:solidFill>
-                            <a:srgbClr val="264B82"/>
-                          </a:solidFill>
-                          <a:latin typeface="Inter" pitchFamily="34" charset="0"/>
-                          <a:ea typeface="Inter" pitchFamily="34" charset="-122"/>
-                          <a:cs typeface="Inter" pitchFamily="34" charset="-120"/>
-                        </a:rPr>
-                        <a:t>1/42</a:t>
-                      </a:r>
-                      <a:endParaRPr lang="en-US" sz="1200" dirty="0">
-                        <a:latin typeface="Inter" charset="0"/>
-                        <a:ea typeface="Inter" charset="0"/>
-                        <a:cs typeface="Inter" charset="0"/>
-                      </a:endParaRPr>
-                    </a:p>
-                  </a:txBody>
-                  <a:tcPr marL="54864" marR="54864" marT="54864" marB="54864" anchor="ctr">
-                    <a:lnL w="9525" cap="flat" cmpd="sng" algn="ctr">
-                      <a:solidFill>
-                        <a:srgbClr val="D5DCE6"/>
-                      </a:solidFill>
-                      <a:prstDash val="solid"/>
-                      <a:round/>
-                      <a:headEnd type="none" w="med" len="med"/>
-                      <a:tailEnd type="none" w="med" len="med"/>
-                    </a:lnL>
-                    <a:lnR w="9525" cap="flat" cmpd="sng" algn="ctr">
-                      <a:solidFill>
-                        <a:srgbClr val="D5DCE6"/>
-                      </a:solidFill>
-                      <a:prstDash val="solid"/>
-                      <a:round/>
-                      <a:headEnd type="none" w="med" len="med"/>
-                      <a:tailEnd type="none" w="med" len="med"/>
-                    </a:lnR>
-                    <a:lnT w="9525" cap="flat" cmpd="sng" algn="ctr">
-                      <a:solidFill>
-                        <a:srgbClr val="D5DCE6"/>
-                      </a:solidFill>
-                      <a:prstDash val="solid"/>
-                      <a:round/>
-                      <a:headEnd type="none" w="med" len="med"/>
-                      <a:tailEnd type="none" w="med" len="med"/>
-                    </a:lnT>
-                    <a:lnB w="9525" cap="flat" cmpd="sng" algn="ctr">
-                      <a:solidFill>
-                        <a:srgbClr val="D5DCE6"/>
-                      </a:solidFill>
-                      <a:prstDash val="solid"/>
-                      <a:round/>
-                      <a:headEnd type="none" w="med" len="med"/>
-                      <a:tailEnd type="none" w="med" len="med"/>
-                    </a:lnB>
-                  </a:tcPr>
-                </a:tc>
-              </a:tr>
-              <a:tr h="301752">
-                <a:tc>
-                  <a:txBody>
-                    <a:bodyPr/>
-                    <a:lstStyle/>
-                    <a:p>
-                      <a:pPr indent="0" marL="0">
-                        <a:buNone/>
-                      </a:pPr>
-                      <a:r>
-                        <a:rPr lang="en-US" sz="1200" dirty="0">
-                          <a:solidFill>
-                            <a:srgbClr val="1F2A3C"/>
-                          </a:solidFill>
-                          <a:latin typeface="Inter" pitchFamily="34" charset="0"/>
-                          <a:ea typeface="Inter" pitchFamily="34" charset="-122"/>
-                          <a:cs typeface="Inter" pitchFamily="34" charset="-120"/>
-                        </a:rPr>
-                        <a:t>Время ответа: медиана</a:t>
-                      </a:r>
-                      <a:endParaRPr lang="en-US" sz="1200" dirty="0">
-                        <a:latin typeface="Inter" charset="0"/>
-                        <a:ea typeface="Inter" charset="0"/>
-                        <a:cs typeface="Inter" charset="0"/>
-                      </a:endParaRPr>
-                    </a:p>
-                  </a:txBody>
-                  <a:tcPr marL="54864" marR="54864" marT="54864" marB="54864" anchor="ctr">
-                    <a:lnL w="9525" cap="flat" cmpd="sng" algn="ctr">
-                      <a:solidFill>
-                        <a:srgbClr val="D5DCE6"/>
-                      </a:solidFill>
-                      <a:prstDash val="solid"/>
-                      <a:round/>
-                      <a:headEnd type="none" w="med" len="med"/>
-                      <a:tailEnd type="none" w="med" len="med"/>
-                    </a:lnL>
-                    <a:lnR w="9525" cap="flat" cmpd="sng" algn="ctr">
-                      <a:solidFill>
-                        <a:srgbClr val="D5DCE6"/>
-                      </a:solidFill>
-                      <a:prstDash val="solid"/>
-                      <a:round/>
-                      <a:headEnd type="none" w="med" len="med"/>
-                      <a:tailEnd type="none" w="med" len="med"/>
-                    </a:lnR>
-                    <a:lnT w="9525" cap="flat" cmpd="sng" algn="ctr">
-                      <a:solidFill>
-                        <a:srgbClr val="D5DCE6"/>
-                      </a:solidFill>
-                      <a:prstDash val="solid"/>
-                      <a:round/>
-                      <a:headEnd type="none" w="med" len="med"/>
-                      <a:tailEnd type="none" w="med" len="med"/>
-                    </a:lnT>
-                    <a:lnB w="9525" cap="flat" cmpd="sng" algn="ctr">
-                      <a:solidFill>
-                        <a:srgbClr val="D5DCE6"/>
-                      </a:solidFill>
-                      <a:prstDash val="solid"/>
-                      <a:round/>
-                      <a:headEnd type="none" w="med" len="med"/>
-                      <a:tailEnd type="none" w="med" len="med"/>
-                    </a:lnB>
-                  </a:tcPr>
-                </a:tc>
-                <a:tc>
-                  <a:txBody>
-                    <a:bodyPr/>
-                    <a:lstStyle/>
-                    <a:p>
-                      <a:pPr algn="r" indent="0" marL="0">
-                        <a:buNone/>
-                      </a:pPr>
-                      <a:r>
-                        <a:rPr lang="en-US" sz="1200" b="1" dirty="0">
-                          <a:solidFill>
-                            <a:srgbClr val="264B82"/>
-                          </a:solidFill>
-                          <a:latin typeface="Inter" pitchFamily="34" charset="0"/>
-                          <a:ea typeface="Inter" pitchFamily="34" charset="-122"/>
-                          <a:cs typeface="Inter" pitchFamily="34" charset="-120"/>
-                        </a:rPr>
-                        <a:t>~50 мс</a:t>
-                      </a:r>
-                      <a:endParaRPr lang="en-US" sz="1200" dirty="0">
-                        <a:latin typeface="Inter" charset="0"/>
-                        <a:ea typeface="Inter" charset="0"/>
-                        <a:cs typeface="Inter" charset="0"/>
-                      </a:endParaRPr>
-                    </a:p>
-                  </a:txBody>
-                  <a:tcPr marL="54864" marR="54864" marT="54864" marB="54864" anchor="ctr">
-                    <a:lnL w="9525" cap="flat" cmpd="sng" algn="ctr">
-                      <a:solidFill>
-                        <a:srgbClr val="D5DCE6"/>
-                      </a:solidFill>
-                      <a:prstDash val="solid"/>
-                      <a:round/>
-                      <a:headEnd type="none" w="med" len="med"/>
-                      <a:tailEnd type="none" w="med" len="med"/>
-                    </a:lnL>
-                    <a:lnR w="9525" cap="flat" cmpd="sng" algn="ctr">
-                      <a:solidFill>
-                        <a:srgbClr val="D5DCE6"/>
-                      </a:solidFill>
-                      <a:prstDash val="solid"/>
-                      <a:round/>
-                      <a:headEnd type="none" w="med" len="med"/>
-                      <a:tailEnd type="none" w="med" len="med"/>
-                    </a:lnR>
-                    <a:lnT w="9525" cap="flat" cmpd="sng" algn="ctr">
-                      <a:solidFill>
-                        <a:srgbClr val="D5DCE6"/>
-                      </a:solidFill>
-                      <a:prstDash val="solid"/>
-                      <a:round/>
-                      <a:headEnd type="none" w="med" len="med"/>
-                      <a:tailEnd type="none" w="med" len="med"/>
-                    </a:lnT>
-                    <a:lnB w="9525" cap="flat" cmpd="sng" algn="ctr">
-                      <a:solidFill>
-                        <a:srgbClr val="D5DCE6"/>
-                      </a:solidFill>
-                      <a:prstDash val="solid"/>
-                      <a:round/>
-                      <a:headEnd type="none" w="med" len="med"/>
-                      <a:tailEnd type="none" w="med" len="med"/>
-                    </a:lnB>
-                  </a:tcPr>
-                </a:tc>
-              </a:tr>
-              <a:tr h="301752">
-                <a:tc>
-                  <a:txBody>
-                    <a:bodyPr/>
-                    <a:lstStyle/>
-                    <a:p>
-                      <a:pPr indent="0" marL="0">
-                        <a:buNone/>
-                      </a:pPr>
-                      <a:r>
-                        <a:rPr lang="en-US" sz="1200" dirty="0">
-                          <a:solidFill>
-                            <a:srgbClr val="1F2A3C"/>
-                          </a:solidFill>
-                          <a:latin typeface="Inter" pitchFamily="34" charset="0"/>
-                          <a:ea typeface="Inter" pitchFamily="34" charset="-122"/>
-                          <a:cs typeface="Inter" pitchFamily="34" charset="-120"/>
-                        </a:rPr>
-                        <a:t>Время ответа: p95*</a:t>
-                      </a:r>
-                      <a:endParaRPr lang="en-US" sz="1200" dirty="0">
-                        <a:latin typeface="Inter" charset="0"/>
-                        <a:ea typeface="Inter" charset="0"/>
-                        <a:cs typeface="Inter" charset="0"/>
-                      </a:endParaRPr>
-                    </a:p>
-                  </a:txBody>
-                  <a:tcPr marL="54864" marR="54864" marT="54864" marB="54864" anchor="ctr">
-                    <a:lnL w="9525" cap="flat" cmpd="sng" algn="ctr">
-                      <a:solidFill>
-                        <a:srgbClr val="D5DCE6"/>
-                      </a:solidFill>
-                      <a:prstDash val="solid"/>
-                      <a:round/>
-                      <a:headEnd type="none" w="med" len="med"/>
-                      <a:tailEnd type="none" w="med" len="med"/>
-                    </a:lnL>
-                    <a:lnR w="9525" cap="flat" cmpd="sng" algn="ctr">
-                      <a:solidFill>
-                        <a:srgbClr val="D5DCE6"/>
-                      </a:solidFill>
-                      <a:prstDash val="solid"/>
-                      <a:round/>
-                      <a:headEnd type="none" w="med" len="med"/>
-                      <a:tailEnd type="none" w="med" len="med"/>
-                    </a:lnR>
-                    <a:lnT w="9525" cap="flat" cmpd="sng" algn="ctr">
-                      <a:solidFill>
-                        <a:srgbClr val="D5DCE6"/>
-                      </a:solidFill>
-                      <a:prstDash val="solid"/>
-                      <a:round/>
-                      <a:headEnd type="none" w="med" len="med"/>
-                      <a:tailEnd type="none" w="med" len="med"/>
-                    </a:lnT>
-                    <a:lnB w="9525" cap="flat" cmpd="sng" algn="ctr">
-                      <a:solidFill>
-                        <a:srgbClr val="D5DCE6"/>
-                      </a:solidFill>
-                      <a:prstDash val="solid"/>
-                      <a:round/>
-                      <a:headEnd type="none" w="med" len="med"/>
-                      <a:tailEnd type="none" w="med" len="med"/>
-                    </a:lnB>
-                  </a:tcPr>
-                </a:tc>
-                <a:tc>
-                  <a:txBody>
-                    <a:bodyPr/>
-                    <a:lstStyle/>
-                    <a:p>
-                      <a:pPr algn="r" indent="0" marL="0">
-                        <a:buNone/>
-                      </a:pPr>
-                      <a:r>
-                        <a:rPr lang="en-US" sz="1200" b="1" dirty="0">
-                          <a:solidFill>
-                            <a:srgbClr val="264B82"/>
-                          </a:solidFill>
-                          <a:latin typeface="Inter" pitchFamily="34" charset="0"/>
-                          <a:ea typeface="Inter" pitchFamily="34" charset="-122"/>
-                          <a:cs typeface="Inter" pitchFamily="34" charset="-120"/>
-                        </a:rPr>
-                        <a:t>99–164 мс</a:t>
+                        <a:t>~50 мс / ~160–190 мс</a:t>
                       </a:r>
                       <a:endParaRPr lang="en-US" sz="1200" dirty="0">
                         <a:latin typeface="Inter" charset="0"/>
@@ -7717,7 +7715,7 @@
                           <a:ea typeface="Inter" pitchFamily="34" charset="-122"/>
                           <a:cs typeface="Inter" pitchFamily="34" charset="-120"/>
                         </a:rPr>
-                        <a:t>58</a:t>
+                        <a:t>62/62</a:t>
                       </a:r>
                       <a:endParaRPr lang="en-US" sz="1200" dirty="0">
                         <a:latin typeface="Inter" charset="0"/>
@@ -7904,14 +7902,14 @@
       </p:graphicFrame>
       <p:sp>
         <p:nvSpPr>
-          <p:cNvPr id="33" name="Text 30"/>
-          <p:cNvSpPr txBox="1"/>
-          <p:nvPr/>
-        </p:nvSpPr>
-        <p:spPr>
-          <a:xfrm>
-            <a:off x="6172200" y="5376672"/>
-            <a:ext cx="5257800" cy="228600"/>
+          <p:cNvPr id="40" name="Text 37"/>
+          <p:cNvSpPr txBox="1"/>
+          <p:nvPr/>
+        </p:nvSpPr>
+        <p:spPr>
+          <a:xfrm>
+            <a:off x="6172200" y="4434840"/>
+            <a:ext cx="5257800" cy="274320"/>
           </a:xfrm>
           <a:prstGeom prst="rect">
             <a:avLst/>
@@ -7930,49 +7928,7 @@
               <a:buNone/>
             </a:pPr>
             <a:r>
-              <a:rPr lang="en-US" sz="1100" dirty="0">
-                <a:solidFill>
-                  <a:srgbClr val="718096"/>
-                </a:solidFill>
-                <a:latin typeface="Inter" pitchFamily="34" charset="0"/>
-                <a:ea typeface="Inter" pitchFamily="34" charset="-122"/>
-                <a:cs typeface="Inter" pitchFamily="34" charset="-120"/>
-              </a:rPr>
-              <a:t>* замер eval-скрипта qa/run_eval.py</a:t>
-            </a:r>
-            <a:endParaRPr lang="en-US" sz="1100" dirty="0"/>
-          </a:p>
-        </p:txBody>
-      </p:sp>
-      <p:sp>
-        <p:nvSpPr>
-          <p:cNvPr id="34" name="Text 31"/>
-          <p:cNvSpPr txBox="1"/>
-          <p:nvPr/>
-        </p:nvSpPr>
-        <p:spPr>
-          <a:xfrm>
-            <a:off x="6172200" y="5623560"/>
-            <a:ext cx="5257800" cy="274320"/>
-          </a:xfrm>
-          <a:prstGeom prst="rect">
-            <a:avLst/>
-          </a:prstGeom>
-          <a:noFill/>
-          <a:ln/>
-        </p:spPr>
-        <p:txBody>
-          <a:bodyPr wrap="square" lIns="0" tIns="0" rIns="0" bIns="0" rtlCol="0" anchor="t"/>
-          <a:lstStyle/>
-          <a:p>
-            <a:pPr indent="0" marL="0">
-              <a:lnSpc>
-                <a:spcPct val="110000"/>
-              </a:lnSpc>
-              <a:buNone/>
-            </a:pPr>
-            <a:r>
-              <a:rPr lang="en-US" sz="1300" b="1" dirty="0">
+              <a:rPr lang="en-US" sz="1200" b="1" dirty="0">
                 <a:solidFill>
                   <a:srgbClr val="1F2A3C"/>
                 </a:solidFill>
@@ -7980,22 +7936,22 @@
                 <a:ea typeface="Inter" pitchFamily="34" charset="-122"/>
                 <a:cs typeface="Inter" pitchFamily="34" charset="-120"/>
               </a:rPr>
-              <a:t>Демо: мебель, одежда, инструменты</a:t>
-            </a:r>
-            <a:endParaRPr lang="en-US" sz="1300" dirty="0"/>
-          </a:p>
-        </p:txBody>
-      </p:sp>
-      <p:sp>
-        <p:nvSpPr>
-          <p:cNvPr id="35" name="Text 32"/>
-          <p:cNvSpPr txBox="1"/>
-          <p:nvPr/>
-        </p:nvSpPr>
-        <p:spPr>
-          <a:xfrm>
-            <a:off x="6172200" y="5897880"/>
-            <a:ext cx="5257800" cy="274320"/>
+              <a:t>Ложные тревоги 1/42 — и эта настоящая ошибка в карточке (2,1 г)</a:t>
+            </a:r>
+            <a:endParaRPr lang="en-US" sz="1200" dirty="0"/>
+          </a:p>
+        </p:txBody>
+      </p:sp>
+      <p:sp>
+        <p:nvSpPr>
+          <p:cNvPr id="41" name="Text 38"/>
+          <p:cNvSpPr txBox="1"/>
+          <p:nvPr/>
+        </p:nvSpPr>
+        <p:spPr>
+          <a:xfrm>
+            <a:off x="6172200" y="4846320"/>
+            <a:ext cx="5257800" cy="502920"/>
           </a:xfrm>
           <a:prstGeom prst="rect">
             <a:avLst/>
@@ -8014,6 +7970,79 @@
               <a:buNone/>
             </a:pPr>
             <a:r>
+              <a:rPr lang="en-US" sz="1050" dirty="0">
+                <a:solidFill>
+                  <a:srgbClr val="718096"/>
+                </a:solidFill>
+                <a:latin typeface="Inter" pitchFamily="34" charset="0"/>
+                <a:ea typeface="Inter" pitchFamily="34" charset="-122"/>
+                <a:cs typeface="Inter" pitchFamily="34" charset="-120"/>
+              </a:rPr>
+              <a:t>* замер eval-скрипта qa/run_eval.py</a:t>
+            </a:r>
+            <a:endParaRPr lang="en-US" sz="1050" dirty="0"/>
+          </a:p>
+          <a:p>
+            <a:pPr indent="0" marL="0">
+              <a:lnSpc>
+                <a:spcPct val="115000"/>
+              </a:lnSpc>
+              <a:buNone/>
+            </a:pPr>
+            <a:r>
+              <a:rPr lang="en-US" sz="1050" dirty="0">
+                <a:solidFill>
+                  <a:srgbClr val="718096"/>
+                </a:solidFill>
+                <a:latin typeface="Inter" pitchFamily="34" charset="0"/>
+                <a:ea typeface="Inter" pitchFamily="34" charset="-122"/>
+                <a:cs typeface="Inter" pitchFamily="34" charset="-120"/>
+              </a:rPr>
+              <a:t>** единицы 8/8, числа 8/8, несуществующие 7/7, опечатки 7/7; набор известен разработчикам — оценка оптимистичная</a:t>
+            </a:r>
+            <a:endParaRPr lang="en-US" sz="1050" dirty="0"/>
+          </a:p>
+        </p:txBody>
+      </p:sp>
+      <p:sp>
+        <p:nvSpPr>
+          <p:cNvPr id="42" name="Text 39"/>
+          <p:cNvSpPr txBox="1"/>
+          <p:nvPr/>
+        </p:nvSpPr>
+        <p:spPr>
+          <a:xfrm>
+            <a:off x="6172200" y="5486400"/>
+            <a:ext cx="5257800" cy="502920"/>
+          </a:xfrm>
+          <a:prstGeom prst="rect">
+            <a:avLst/>
+          </a:prstGeom>
+          <a:noFill/>
+          <a:ln/>
+        </p:spPr>
+        <p:txBody>
+          <a:bodyPr wrap="square" lIns="0" tIns="0" rIns="0" bIns="0" rtlCol="0" anchor="t"/>
+          <a:lstStyle/>
+          <a:p>
+            <a:pPr indent="0" marL="0">
+              <a:lnSpc>
+                <a:spcPct val="115000"/>
+              </a:lnSpc>
+              <a:buNone/>
+            </a:pPr>
+            <a:r>
+              <a:rPr lang="en-US" sz="1200" b="1" dirty="0">
+                <a:solidFill>
+                  <a:srgbClr val="1F2A3C"/>
+                </a:solidFill>
+                <a:latin typeface="Inter" pitchFamily="34" charset="0"/>
+                <a:ea typeface="Inter" pitchFamily="34" charset="-122"/>
+                <a:cs typeface="Inter" pitchFamily="34" charset="-120"/>
+              </a:rPr>
+              <a:t>Демо: </a:t>
+            </a:r>
+            <a:r>
               <a:rPr lang="en-US" sz="1200" dirty="0">
                 <a:solidFill>
                   <a:srgbClr val="4A5568"/>
@@ -8022,7 +8051,7 @@
                 <a:ea typeface="Inter" pitchFamily="34" charset="-122"/>
                 <a:cs typeface="Inter" pitchFamily="34" charset="-120"/>
               </a:rPr>
-              <a:t>Бейджи, правка в один клик, на выходе группа из 2–3 вариаций.</a:t>
+              <a:t>мебель, одежда, инструменты; на выходе группа из 2–3 вариаций.</a:t>
             </a:r>
             <a:endParaRPr lang="en-US" sz="1200" dirty="0"/>
           </a:p>

</xml_diff>